<commit_message>
Datensatz auf 18 Monate erweitern, Statistik-Notebook ergänzen, Doku/PPT/Dashboard aktualisieren
Rohdaten um Januar–März 2025 erweitert (jetzt 18 Berichtsmonate, Jan 2025–Jun 2026).
Notebooks, MD-Doku und README auf die neuen Kennzahlen angepasst. Neues Notebook
03_Statistik.ipynb (Korrelation, Hypothesentest, Regression) inkl. MD/03_Statistik.md.
Projektdokumentation und -präsentation um Kapitel "Vertiefte statistische Analyse"
ergänzt und durchgängig auf die 18-Monats-Zahlen aktualisiert. Tabellen-Scrollbar-Fix
im Dashboard nachgezogen.

Co-Authored-By: Claude Sonnet 5 <noreply@anthropic.com>
</commit_message>
<xml_diff>
--- a/Dok/Projektpraesentation.pptx
+++ b/Dok/Projektpraesentation.pptx
@@ -22,6 +22,15 @@
     <p:sldId id="270" r:id="rId16"/>
     <p:sldId id="271" r:id="rId17"/>
     <p:sldId id="272" r:id="rId18"/>
+    <p:sldId id="277" r:id="rId28"/>
+    <p:sldId id="278" r:id="rId29"/>
+    <p:sldId id="279" r:id="rId30"/>
+    <p:sldId id="280" r:id="rId31"/>
+    <p:sldId id="281" r:id="rId32"/>
+    <p:sldId id="282" r:id="rId33"/>
+    <p:sldId id="283" r:id="rId34"/>
+    <p:sldId id="284" r:id="rId35"/>
+    <p:sldId id="285" r:id="rId36"/>
     <p:sldId id="273" r:id="rId19"/>
     <p:sldId id="274" r:id="rId20"/>
     <p:sldId id="275" r:id="rId21"/>
@@ -4008,7 +4017,7 @@
                 </a:solidFill>
                 <a:latin typeface="Calibri"/>
               </a:rPr>
-              <a:t>Personen in BG (Fläche) sowie Bedarfsgemeinschaften, Arbeitslose und Langzeitarbeitslose (überlappende Balken), April 2025 – Juni 2026.</a:t>
+              <a:t>Personen in BG (Fläche) sowie Bedarfsgemeinschaften, Arbeitslose und Langzeitarbeitslose (überlappende Balken), Januar 2025 – Juni 2026.</a:t>
             </a:r>
           </a:p>
         </p:txBody>
@@ -4422,7 +4431,7 @@
                 </a:solidFill>
                 <a:latin typeface="Calibri"/>
               </a:rPr>
-              <a:t>Deutlichster Trend im Datensatz: Anteil an allen Arbeitslosen von 36,1 % auf 47,3 % gestiegen.</a:t>
+              <a:t>Deutlichster Trend im Datensatz: Anteil an allen Arbeitslosen von 34,1 % auf 47,3 % gestiegen.</a:t>
             </a:r>
           </a:p>
         </p:txBody>
@@ -5258,7 +5267,7 @@
                 </a:solidFill>
                 <a:latin typeface="Calibri"/>
               </a:rPr>
-              <a:t>●  Arbeitslose (Bestand): 1.457 → 1.500 — leicht gestiegen, Spanne 1.438–1.587.</a:t>
+              <a:t>●  Arbeitslose (Bestand): 1.470 → 1.500 — leicht gestiegen, Spanne 1.382–1.587.</a:t>
             </a:r>
           </a:p>
           <a:p>
@@ -5290,7 +5299,7 @@
                 </a:solidFill>
                 <a:latin typeface="Calibri"/>
               </a:rPr>
-              <a:t>●  Langzeitarbeitslosigkeit: deutlichster Trend — 526 → 709 Personen (+ rund 35 %).</a:t>
+              <a:t>●  Langzeitarbeitslosigkeit: deutlichster Trend — 502 → 709 Personen (+ rund 41 %).</a:t>
             </a:r>
           </a:p>
           <a:p>
@@ -5306,7 +5315,7 @@
                 </a:solidFill>
                 <a:latin typeface="Calibri"/>
               </a:rPr>
-              <a:t>●  Bedarfsgemeinschaften / Personen in BG: beide rückläufig (je ca. −5 %).</a:t>
+              <a:t>●  Bedarfsgemeinschaften / Personen in BG: beide rückläufig (ca. −4 % bzw. −6 %).</a:t>
             </a:r>
           </a:p>
           <a:p>
@@ -5336,12 +5345,12 @@
 </file>
 
 <file path=ppt/slides/slide18.xml><?xml version="1.0" encoding="utf-8"?>
-<p:sld xmlns:a="http://schemas.openxmlformats.org/drawingml/2006/main" xmlns:r="http://schemas.openxmlformats.org/officeDocument/2006/relationships" xmlns:p="http://schemas.openxmlformats.org/presentationml/2006/main">
+<p:sld xmlns:a="http://schemas.openxmlformats.org/drawingml/2006/main" xmlns:p="http://schemas.openxmlformats.org/presentationml/2006/main" xmlns:r="http://schemas.openxmlformats.org/officeDocument/2006/relationships">
   <p:cSld>
     <p:bg>
       <p:bgPr>
         <a:solidFill>
-          <a:srgbClr val="DC2626"/>
+          <a:srgbClr val="0D9488"/>
         </a:solidFill>
         <a:effectLst/>
       </p:bgPr>
@@ -5352,14 +5361,7 @@
         <p:cNvGrpSpPr/>
         <p:nvPr/>
       </p:nvGrpSpPr>
-      <p:grpSpPr>
-        <a:xfrm>
-          <a:off x="0" y="0"/>
-          <a:ext cx="0" cy="0"/>
-          <a:chOff x="0" y="0"/>
-          <a:chExt cx="0" cy="0"/>
-        </a:xfrm>
-      </p:grpSpPr>
+      <p:grpSpPr/>
       <p:sp>
         <p:nvSpPr>
           <p:cNvPr id="2" name="Rectangle 1"/>
@@ -5369,7 +5371,7 @@
         <p:spPr>
           <a:xfrm>
             <a:off x="0" y="2951999"/>
-            <a:ext cx="12193200" cy="54000"/>
+            <a:ext cx="12193588" cy="54000"/>
           </a:xfrm>
           <a:prstGeom prst="rect">
             <a:avLst/>
@@ -5401,7 +5403,6 @@
           <a:lstStyle/>
           <a:p>
             <a:pPr algn="ctr"/>
-            <a:endParaRPr/>
           </a:p>
         </p:txBody>
       </p:sp>
@@ -5413,78 +5414,8 @@
         </p:nvSpPr>
         <p:spPr>
           <a:xfrm>
-            <a:off x="720000" y="1944000"/>
-            <a:ext cx="10753200" cy="540000"/>
-          </a:xfrm>
-          <a:prstGeom prst="rect">
-            <a:avLst/>
-          </a:prstGeom>
-          <a:noFill/>
-        </p:spPr>
-        <p:txBody>
-          <a:bodyPr wrap="square" anchor="t">
-            <a:spAutoFit/>
-          </a:bodyPr>
-          <a:lstStyle/>
-          <a:p>
-            <a:pPr algn="l"/>
-            <a:r>
-              <a:rPr sz="2200" b="1" i="0">
-                <a:solidFill>
-                  <a:srgbClr val="BFDBFE"/>
-                </a:solidFill>
-                <a:latin typeface="Calibri"/>
-              </a:rPr>
-              <a:t>KAPITEL 4</a:t>
-            </a:r>
-          </a:p>
-        </p:txBody>
-      </p:sp>
-      <p:sp>
-        <p:nvSpPr>
-          <p:cNvPr id="4" name="TextBox 3"/>
-          <p:cNvSpPr txBox="1"/>
-          <p:nvPr/>
-        </p:nvSpPr>
-        <p:spPr>
-          <a:xfrm>
-            <a:off x="720000" y="2196000"/>
-            <a:ext cx="10753200" cy="792000"/>
-          </a:xfrm>
-          <a:prstGeom prst="rect">
-            <a:avLst/>
-          </a:prstGeom>
-          <a:noFill/>
-        </p:spPr>
-        <p:txBody>
-          <a:bodyPr wrap="square" anchor="t">
-            <a:spAutoFit/>
-          </a:bodyPr>
-          <a:lstStyle/>
-          <a:p>
-            <a:pPr algn="l"/>
-            <a:r>
-              <a:rPr sz="4000" b="1" i="0">
-                <a:solidFill>
-                  <a:srgbClr val="FFFFFF"/>
-                </a:solidFill>
-                <a:latin typeface="Calibri"/>
-              </a:rPr>
-              <a:t>Fazit und Ausblick</a:t>
-            </a:r>
-          </a:p>
-        </p:txBody>
-      </p:sp>
-      <p:sp>
-        <p:nvSpPr>
-          <p:cNvPr id="5" name="TextBox 4"/>
-          <p:cNvSpPr txBox="1"/>
-          <p:nvPr/>
-        </p:nvSpPr>
-        <p:spPr>
-          <a:xfrm>
-            <a:off x="720000" y="3311999"/>
-            <a:ext cx="10753200" cy="2880000"/>
+            <a:off x="720000" y="1314000"/>
+            <a:ext cx="10753200" cy="259200"/>
           </a:xfrm>
           <a:prstGeom prst="rect">
             <a:avLst/>
@@ -5497,35 +5428,119 @@
           </a:bodyPr>
           <a:lstStyle/>
           <a:p>
+            <a:r>
+              <a:rPr sz="2200" b="1" i="0">
+                <a:solidFill>
+                  <a:srgbClr val="BFDBFE"/>
+                </a:solidFill>
+                <a:latin typeface="Calibri"/>
+              </a:rPr>
+              <a:t>KAPITEL 4</a:t>
+            </a:r>
+          </a:p>
+        </p:txBody>
+      </p:sp>
+      <p:sp>
+        <p:nvSpPr>
+          <p:cNvPr id="4" name="TextBox 3"/>
+          <p:cNvSpPr txBox="1"/>
+          <p:nvPr/>
+        </p:nvSpPr>
+        <p:spPr>
+          <a:xfrm>
+            <a:off x="720000" y="1602000"/>
+            <a:ext cx="10753200" cy="792000"/>
+          </a:xfrm>
+          <a:prstGeom prst="rect">
+            <a:avLst/>
+          </a:prstGeom>
+          <a:noFill/>
+        </p:spPr>
+        <p:txBody>
+          <a:bodyPr wrap="square">
+            <a:spAutoFit/>
+          </a:bodyPr>
+          <a:lstStyle/>
+          <a:p>
+            <a:r>
+              <a:rPr sz="4000" b="1" i="0">
+                <a:solidFill>
+                  <a:srgbClr val="FFFFFF"/>
+                </a:solidFill>
+                <a:latin typeface="Calibri"/>
+              </a:rPr>
+              <a:t>Vertiefte statistische Analyse</a:t>
+            </a:r>
+          </a:p>
+        </p:txBody>
+      </p:sp>
+      <p:sp>
+        <p:nvSpPr>
+          <p:cNvPr id="5" name="TextBox 4"/>
+          <p:cNvSpPr txBox="1"/>
+          <p:nvPr/>
+        </p:nvSpPr>
+        <p:spPr>
+          <a:xfrm>
+            <a:off x="720000" y="3311999"/>
+            <a:ext cx="10753200" cy="2880000"/>
+          </a:xfrm>
+          <a:prstGeom prst="rect">
+            <a:avLst/>
+          </a:prstGeom>
+          <a:noFill/>
+        </p:spPr>
+        <p:txBody>
+          <a:bodyPr wrap="square">
+            <a:spAutoFit/>
+          </a:bodyPr>
+          <a:lstStyle/>
+          <a:p>
             <a:pPr>
               <a:spcAft>
-                <a:spcPts val="1200"/>
+                <a:spcPts val="1400"/>
               </a:spcAft>
             </a:pPr>
             <a:r>
-              <a:rPr sz="1800">
+              <a:rPr sz="1800" b="0" i="0">
                 <a:solidFill>
                   <a:srgbClr val="E0E7FF"/>
                 </a:solidFill>
                 <a:latin typeface="Calibri"/>
               </a:rPr>
-              <a:t>●  Zusammenfassung der Projektergebnisse</a:t>
+              <a:t>●  Deskriptive Statistik im Detail (Median, Varianz, IQR, Variationskoeffizient)</a:t>
             </a:r>
           </a:p>
           <a:p>
             <a:pPr>
               <a:spcAft>
-                <a:spcPts val="1200"/>
+                <a:spcPts val="1400"/>
               </a:spcAft>
             </a:pPr>
             <a:r>
-              <a:rPr sz="1800">
+              <a:rPr sz="1800" b="0" i="0">
                 <a:solidFill>
                   <a:srgbClr val="E0E7FF"/>
                 </a:solidFill>
                 <a:latin typeface="Calibri"/>
               </a:rPr>
-              <a:t>●  Priorisierte Themen für die Fortsetzung</a:t>
+              <a:t>●  Korrelationsanalyse und Verteilungen</a:t>
+            </a:r>
+          </a:p>
+          <a:p>
+            <a:pPr>
+              <a:spcAft>
+                <a:spcPts val="1400"/>
+              </a:spcAft>
+            </a:pPr>
+            <a:r>
+              <a:rPr sz="1800" b="0" i="0">
+                <a:solidFill>
+                  <a:srgbClr val="E0E7FF"/>
+                </a:solidFill>
+                <a:latin typeface="Calibri"/>
+              </a:rPr>
+              <a:t>●  Inferenzstatistik (Hypothesentest) und lineare Regression</a:t>
             </a:r>
           </a:p>
         </p:txBody>
@@ -5539,30 +5554,15 @@
 </file>
 
 <file path=ppt/slides/slide19.xml><?xml version="1.0" encoding="utf-8"?>
-<p:sld xmlns:a="http://schemas.openxmlformats.org/drawingml/2006/main" xmlns:r="http://schemas.openxmlformats.org/officeDocument/2006/relationships" xmlns:p="http://schemas.openxmlformats.org/presentationml/2006/main">
+<p:sld xmlns:a="http://schemas.openxmlformats.org/drawingml/2006/main" xmlns:p="http://schemas.openxmlformats.org/presentationml/2006/main" xmlns:r="http://schemas.openxmlformats.org/officeDocument/2006/relationships">
   <p:cSld>
-    <p:bg>
-      <p:bgPr>
-        <a:solidFill>
-          <a:srgbClr val="FFFFFF"/>
-        </a:solidFill>
-        <a:effectLst/>
-      </p:bgPr>
-    </p:bg>
     <p:spTree>
       <p:nvGrpSpPr>
         <p:cNvPr id="1" name=""/>
         <p:cNvGrpSpPr/>
         <p:nvPr/>
       </p:nvGrpSpPr>
-      <p:grpSpPr>
-        <a:xfrm>
-          <a:off x="0" y="0"/>
-          <a:ext cx="0" cy="0"/>
-          <a:chOff x="0" y="0"/>
-          <a:chExt cx="0" cy="0"/>
-        </a:xfrm>
-      </p:grpSpPr>
+      <p:grpSpPr/>
       <p:sp>
         <p:nvSpPr>
           <p:cNvPr id="2" name="Rectangle 1"/>
@@ -5572,13 +5572,13 @@
         <p:spPr>
           <a:xfrm>
             <a:off x="0" y="0"/>
-            <a:ext cx="12193200" cy="936000"/>
+            <a:ext cx="12193588" cy="936000"/>
           </a:xfrm>
           <a:prstGeom prst="rect">
             <a:avLst/>
           </a:prstGeom>
           <a:solidFill>
-            <a:srgbClr val="DC2626"/>
+            <a:srgbClr val="2563EB"/>
           </a:solidFill>
           <a:ln>
             <a:noFill/>
@@ -5604,7 +5604,6 @@
           <a:lstStyle/>
           <a:p>
             <a:pPr algn="ctr"/>
-            <a:endParaRPr/>
           </a:p>
         </p:txBody>
       </p:sp>
@@ -5618,76 +5617,6 @@
           <a:xfrm>
             <a:off x="432000" y="90000"/>
             <a:ext cx="11329200" cy="251999"/>
-          </a:xfrm>
-          <a:prstGeom prst="rect">
-            <a:avLst/>
-          </a:prstGeom>
-          <a:noFill/>
-        </p:spPr>
-        <p:txBody>
-          <a:bodyPr wrap="square" anchor="t">
-            <a:spAutoFit/>
-          </a:bodyPr>
-          <a:lstStyle/>
-          <a:p>
-            <a:pPr algn="l"/>
-            <a:r>
-              <a:rPr sz="1400" b="1" i="0">
-                <a:solidFill>
-                  <a:srgbClr val="FFFFFF"/>
-                </a:solidFill>
-                <a:latin typeface="Calibri"/>
-              </a:rPr>
-              <a:t>4.1</a:t>
-            </a:r>
-          </a:p>
-        </p:txBody>
-      </p:sp>
-      <p:sp>
-        <p:nvSpPr>
-          <p:cNvPr id="4" name="TextBox 3"/>
-          <p:cNvSpPr txBox="1"/>
-          <p:nvPr/>
-        </p:nvSpPr>
-        <p:spPr>
-          <a:xfrm>
-            <a:off x="432000" y="306000"/>
-            <a:ext cx="11329200" cy="540000"/>
-          </a:xfrm>
-          <a:prstGeom prst="rect">
-            <a:avLst/>
-          </a:prstGeom>
-          <a:noFill/>
-        </p:spPr>
-        <p:txBody>
-          <a:bodyPr wrap="square" anchor="t">
-            <a:spAutoFit/>
-          </a:bodyPr>
-          <a:lstStyle/>
-          <a:p>
-            <a:pPr algn="l"/>
-            <a:r>
-              <a:rPr sz="2800" b="1" i="0">
-                <a:solidFill>
-                  <a:srgbClr val="FFFFFF"/>
-                </a:solidFill>
-                <a:latin typeface="Calibri"/>
-              </a:rPr>
-              <a:t>Fazit</a:t>
-            </a:r>
-          </a:p>
-        </p:txBody>
-      </p:sp>
-      <p:sp>
-        <p:nvSpPr>
-          <p:cNvPr id="5" name="TextBox 4"/>
-          <p:cNvSpPr txBox="1"/>
-          <p:nvPr/>
-        </p:nvSpPr>
-        <p:spPr>
-          <a:xfrm>
-            <a:off x="503999" y="1224000"/>
-            <a:ext cx="11185201" cy="5238000"/>
           </a:xfrm>
           <a:prstGeom prst="rect">
             <a:avLst/>
@@ -5700,67 +5629,151 @@
           </a:bodyPr>
           <a:lstStyle/>
           <a:p>
+            <a:r>
+              <a:rPr sz="1400" b="1" i="0">
+                <a:solidFill>
+                  <a:srgbClr val="FFFFFF"/>
+                </a:solidFill>
+                <a:latin typeface="Calibri"/>
+              </a:rPr>
+              <a:t>4.1</a:t>
+            </a:r>
+          </a:p>
+        </p:txBody>
+      </p:sp>
+      <p:sp>
+        <p:nvSpPr>
+          <p:cNvPr id="4" name="TextBox 3"/>
+          <p:cNvSpPr txBox="1"/>
+          <p:nvPr/>
+        </p:nvSpPr>
+        <p:spPr>
+          <a:xfrm>
+            <a:off x="432000" y="306000"/>
+            <a:ext cx="11329200" cy="540000"/>
+          </a:xfrm>
+          <a:prstGeom prst="rect">
+            <a:avLst/>
+          </a:prstGeom>
+          <a:noFill/>
+        </p:spPr>
+        <p:txBody>
+          <a:bodyPr wrap="square">
+            <a:spAutoFit/>
+          </a:bodyPr>
+          <a:lstStyle/>
+          <a:p>
+            <a:r>
+              <a:rPr sz="2800" b="1" i="0">
+                <a:solidFill>
+                  <a:srgbClr val="FFFFFF"/>
+                </a:solidFill>
+                <a:latin typeface="Calibri"/>
+              </a:rPr>
+              <a:t>Deskriptive Statistik im Detail</a:t>
+            </a:r>
+          </a:p>
+        </p:txBody>
+      </p:sp>
+      <p:sp>
+        <p:nvSpPr>
+          <p:cNvPr id="5" name="TextBox 4"/>
+          <p:cNvSpPr txBox="1"/>
+          <p:nvPr/>
+        </p:nvSpPr>
+        <p:spPr>
+          <a:xfrm>
+            <a:off x="503999" y="1224000"/>
+            <a:ext cx="11185200" cy="5238000"/>
+          </a:xfrm>
+          <a:prstGeom prst="rect">
+            <a:avLst/>
+          </a:prstGeom>
+          <a:noFill/>
+        </p:spPr>
+        <p:txBody>
+          <a:bodyPr wrap="square">
+            <a:spAutoFit/>
+          </a:bodyPr>
+          <a:lstStyle/>
+          <a:p>
             <a:pPr>
               <a:spcAft>
-                <a:spcPts val="1400"/>
+                <a:spcPts val="1600"/>
               </a:spcAft>
             </a:pPr>
             <a:r>
-              <a:rPr sz="1800">
+              <a:rPr sz="1800" b="0" i="0">
                 <a:solidFill>
                   <a:srgbClr val="374151"/>
                 </a:solidFill>
                 <a:latin typeface="Calibri"/>
               </a:rPr>
-              <a:t>●  Aus 15 Excel-Berichten mit über 20 Tabellenblättern wurde eine strukturierte Zeitreihe mit 9 zentralen SGB-II-Kennzahlen erstellt.</a:t>
+              <a:t>●  Arbeitslose (Bestand): Ø 1.504,0, Median 1.513,0, Variationskoeffizient ≈ 3,9 %</a:t>
             </a:r>
           </a:p>
           <a:p>
             <a:pPr>
               <a:spcAft>
-                <a:spcPts val="1400"/>
+                <a:spcPts val="1600"/>
               </a:spcAft>
             </a:pPr>
             <a:r>
-              <a:rPr sz="1800">
+              <a:rPr sz="1800" b="0" i="0">
                 <a:solidFill>
                   <a:srgbClr val="374151"/>
                 </a:solidFill>
                 <a:latin typeface="Calibri"/>
               </a:rPr>
-              <a:t>●  5 interaktive Diagramme sowie eine Kennzahlen-Vergleichstabelle machen die Entwicklung nachvollziehbar.</a:t>
+              <a:t>●  Langzeitarbeitslose: Ø 602,2, Median 599,0, Variationskoeffizient ≈ 11,8 %</a:t>
             </a:r>
           </a:p>
           <a:p>
             <a:pPr>
               <a:spcAft>
-                <a:spcPts val="1400"/>
+                <a:spcPts val="1600"/>
               </a:spcAft>
             </a:pPr>
             <a:r>
-              <a:rPr sz="1800">
+              <a:rPr sz="1800" b="0" i="0">
                 <a:solidFill>
                   <a:srgbClr val="374151"/>
                 </a:solidFill>
                 <a:latin typeface="Calibri"/>
               </a:rPr>
-              <a:t>●  Ergebnisse zusätzlich in einem öffentlichen Streamlit-Dashboard bereitgestellt.</a:t>
+              <a:t>●  Bedarfsgemeinschaften: Ø 2.691,7, Median 2.692,1, Variationskoeffizient ≈ 2,1 %</a:t>
             </a:r>
           </a:p>
           <a:p>
             <a:pPr>
               <a:spcAft>
-                <a:spcPts val="1400"/>
+                <a:spcPts val="1600"/>
               </a:spcAft>
             </a:pPr>
             <a:r>
-              <a:rPr sz="1800">
+              <a:rPr sz="1800" b="0" i="0">
                 <a:solidFill>
                   <a:srgbClr val="374151"/>
                 </a:solidFill>
                 <a:latin typeface="Calibri"/>
               </a:rPr>
-              <a:t>●  Kernbefund: Arbeitslosenbestand/-quote stabil, aber deutliche Verschärfung der Langzeitarbeitslosigkeit — eine Entwicklung, die in den Rohdaten allein kaum erkennbar gewesen wäre.</a:t>
+              <a:t>●  Personen in BG: Ø 5.247,4, Median 5.216,6, Variationskoeffizient ≈ 2,4 %</a:t>
+            </a:r>
+          </a:p>
+          <a:p>
+            <a:pPr>
+              <a:spcAft>
+                <a:spcPts val="1600"/>
+              </a:spcAft>
+            </a:pPr>
+            <a:r>
+              <a:rPr sz="1800" b="0" i="0">
+                <a:solidFill>
+                  <a:srgbClr val="374151"/>
+                </a:solidFill>
+                <a:latin typeface="Calibri"/>
+              </a:rPr>
+              <a:t>●  Langzeitarbeitslose zeigen die mit Abstand stärkste relative Veränderung — Bedarfsgemeinschaften und Personen in BG sind am stabilsten</a:t>
             </a:r>
           </a:p>
         </p:txBody>
@@ -6258,7 +6271,7 @@
         </p:nvSpPr>
         <p:spPr>
           <a:xfrm>
-            <a:off x="503999" y="4032000"/>
+            <a:off x="503999" y="4896000"/>
             <a:ext cx="503999" cy="503999"/>
           </a:xfrm>
           <a:prstGeom prst="rect">
@@ -6303,7 +6316,7 @@
         </p:nvSpPr>
         <p:spPr>
           <a:xfrm>
-            <a:off x="503999" y="4032000"/>
+            <a:off x="503999" y="4896000"/>
             <a:ext cx="503999" cy="503999"/>
           </a:xfrm>
           <a:prstGeom prst="rect">
@@ -6325,7 +6338,7 @@
                 </a:solidFill>
                 <a:latin typeface="Calibri"/>
               </a:rPr>
-              <a:t>4</a:t>
+              <a:t>5</a:t>
             </a:r>
           </a:p>
         </p:txBody>
@@ -6338,7 +6351,7 @@
         </p:nvSpPr>
         <p:spPr>
           <a:xfrm>
-            <a:off x="1152000" y="4032000"/>
+            <a:off x="1152000" y="4896000"/>
             <a:ext cx="7200000" cy="503999"/>
           </a:xfrm>
           <a:prstGeom prst="rect">
@@ -6361,6 +6374,119 @@
                 <a:latin typeface="Calibri"/>
               </a:rPr>
               <a:t>Fazit und Ausblick</a:t>
+            </a:r>
+          </a:p>
+        </p:txBody>
+      </p:sp>
+      <p:sp>
+        <p:nvSpPr>
+          <p:cNvPr id="17" name="Rectangle 16"/>
+          <p:cNvSpPr/>
+          <p:nvPr/>
+        </p:nvSpPr>
+        <p:spPr>
+          <a:xfrm>
+            <a:off x="503999" y="4031999"/>
+            <a:ext cx="503999" cy="503999"/>
+          </a:xfrm>
+          <a:prstGeom prst="rect">
+            <a:avLst/>
+          </a:prstGeom>
+          <a:solidFill>
+            <a:srgbClr val="0D9488"/>
+          </a:solidFill>
+          <a:ln>
+            <a:noFill/>
+          </a:ln>
+          <a:effectLst/>
+        </p:spPr>
+        <p:style>
+          <a:lnRef idx="1">
+            <a:schemeClr val="accent1"/>
+          </a:lnRef>
+          <a:fillRef idx="3">
+            <a:schemeClr val="accent1"/>
+          </a:fillRef>
+          <a:effectRef idx="2">
+            <a:schemeClr val="accent1"/>
+          </a:effectRef>
+          <a:fontRef idx="minor">
+            <a:schemeClr val="lt1"/>
+          </a:fontRef>
+        </p:style>
+        <p:txBody>
+          <a:bodyPr rtlCol="0" anchor="ctr"/>
+          <a:lstStyle/>
+          <a:p>
+            <a:pPr algn="ctr"/>
+          </a:p>
+        </p:txBody>
+      </p:sp>
+      <p:sp>
+        <p:nvSpPr>
+          <p:cNvPr id="18" name="TextBox 17"/>
+          <p:cNvSpPr txBox="1"/>
+          <p:nvPr/>
+        </p:nvSpPr>
+        <p:spPr>
+          <a:xfrm>
+            <a:off x="503999" y="4031999"/>
+            <a:ext cx="503999" cy="503999"/>
+          </a:xfrm>
+          <a:prstGeom prst="rect">
+            <a:avLst/>
+          </a:prstGeom>
+          <a:noFill/>
+        </p:spPr>
+        <p:txBody>
+          <a:bodyPr wrap="square">
+            <a:spAutoFit/>
+          </a:bodyPr>
+          <a:lstStyle/>
+          <a:p>
+            <a:pPr algn="ctr"/>
+            <a:r>
+              <a:rPr sz="2400" b="1" i="0">
+                <a:solidFill>
+                  <a:srgbClr val="FFFFFF"/>
+                </a:solidFill>
+                <a:latin typeface="Calibri"/>
+              </a:rPr>
+              <a:t>4</a:t>
+            </a:r>
+          </a:p>
+        </p:txBody>
+      </p:sp>
+      <p:sp>
+        <p:nvSpPr>
+          <p:cNvPr id="19" name="TextBox 18"/>
+          <p:cNvSpPr txBox="1"/>
+          <p:nvPr/>
+        </p:nvSpPr>
+        <p:spPr>
+          <a:xfrm>
+            <a:off x="1152000" y="4031999"/>
+            <a:ext cx="7200000" cy="503999"/>
+          </a:xfrm>
+          <a:prstGeom prst="rect">
+            <a:avLst/>
+          </a:prstGeom>
+          <a:noFill/>
+        </p:spPr>
+        <p:txBody>
+          <a:bodyPr wrap="square">
+            <a:spAutoFit/>
+          </a:bodyPr>
+          <a:lstStyle/>
+          <a:p>
+            <a:r>
+              <a:rPr sz="2400" b="1" i="0">
+                <a:solidFill>
+                  <a:srgbClr val="374151"/>
+                </a:solidFill>
+                <a:latin typeface="Calibri"/>
+              </a:rPr>
+              <a:t>Vertiefte statistische Analyse</a:t>
             </a:r>
           </a:p>
         </p:txBody>
@@ -6374,6 +6500,1616 @@
 </file>
 
 <file path=ppt/slides/slide20.xml><?xml version="1.0" encoding="utf-8"?>
+<p:sld xmlns:a="http://schemas.openxmlformats.org/drawingml/2006/main" xmlns:p="http://schemas.openxmlformats.org/presentationml/2006/main" xmlns:r="http://schemas.openxmlformats.org/officeDocument/2006/relationships">
+  <p:cSld>
+    <p:spTree>
+      <p:nvGrpSpPr>
+        <p:cNvPr id="1" name=""/>
+        <p:cNvGrpSpPr/>
+        <p:nvPr/>
+      </p:nvGrpSpPr>
+      <p:grpSpPr/>
+      <p:sp>
+        <p:nvSpPr>
+          <p:cNvPr id="2" name="Rectangle 1"/>
+          <p:cNvSpPr/>
+          <p:nvPr/>
+        </p:nvSpPr>
+        <p:spPr>
+          <a:xfrm>
+            <a:off x="0" y="0"/>
+            <a:ext cx="12193588" cy="936000"/>
+          </a:xfrm>
+          <a:prstGeom prst="rect">
+            <a:avLst/>
+          </a:prstGeom>
+          <a:solidFill>
+            <a:srgbClr val="7C3AED"/>
+          </a:solidFill>
+          <a:ln>
+            <a:noFill/>
+          </a:ln>
+          <a:effectLst/>
+        </p:spPr>
+        <p:style>
+          <a:lnRef idx="1">
+            <a:schemeClr val="accent1"/>
+          </a:lnRef>
+          <a:fillRef idx="3">
+            <a:schemeClr val="accent1"/>
+          </a:fillRef>
+          <a:effectRef idx="2">
+            <a:schemeClr val="accent1"/>
+          </a:effectRef>
+          <a:fontRef idx="minor">
+            <a:schemeClr val="lt1"/>
+          </a:fontRef>
+        </p:style>
+        <p:txBody>
+          <a:bodyPr rtlCol="0" anchor="ctr"/>
+          <a:lstStyle/>
+          <a:p>
+            <a:pPr algn="ctr"/>
+          </a:p>
+        </p:txBody>
+      </p:sp>
+      <p:sp>
+        <p:nvSpPr>
+          <p:cNvPr id="3" name="TextBox 2"/>
+          <p:cNvSpPr txBox="1"/>
+          <p:nvPr/>
+        </p:nvSpPr>
+        <p:spPr>
+          <a:xfrm>
+            <a:off x="432000" y="90000"/>
+            <a:ext cx="11329200" cy="251999"/>
+          </a:xfrm>
+          <a:prstGeom prst="rect">
+            <a:avLst/>
+          </a:prstGeom>
+          <a:noFill/>
+        </p:spPr>
+        <p:txBody>
+          <a:bodyPr wrap="square">
+            <a:spAutoFit/>
+          </a:bodyPr>
+          <a:lstStyle/>
+          <a:p>
+            <a:r>
+              <a:rPr sz="1400" b="1" i="0">
+                <a:solidFill>
+                  <a:srgbClr val="FFFFFF"/>
+                </a:solidFill>
+                <a:latin typeface="Calibri"/>
+              </a:rPr>
+              <a:t>4.2</a:t>
+            </a:r>
+          </a:p>
+        </p:txBody>
+      </p:sp>
+      <p:sp>
+        <p:nvSpPr>
+          <p:cNvPr id="4" name="TextBox 3"/>
+          <p:cNvSpPr txBox="1"/>
+          <p:nvPr/>
+        </p:nvSpPr>
+        <p:spPr>
+          <a:xfrm>
+            <a:off x="432000" y="306000"/>
+            <a:ext cx="11329200" cy="540000"/>
+          </a:xfrm>
+          <a:prstGeom prst="rect">
+            <a:avLst/>
+          </a:prstGeom>
+          <a:noFill/>
+        </p:spPr>
+        <p:txBody>
+          <a:bodyPr wrap="square">
+            <a:spAutoFit/>
+          </a:bodyPr>
+          <a:lstStyle/>
+          <a:p>
+            <a:r>
+              <a:rPr sz="2800" b="1" i="0">
+                <a:solidFill>
+                  <a:srgbClr val="FFFFFF"/>
+                </a:solidFill>
+                <a:latin typeface="Calibri"/>
+              </a:rPr>
+              <a:t>Korrelationsanalyse: Korrelationsmatrix</a:t>
+            </a:r>
+          </a:p>
+        </p:txBody>
+      </p:sp>
+      <p:pic>
+        <p:nvPicPr>
+          <p:cNvPr id="5" name="Picture 4" descr="abb6_korrelation.png"/>
+          <p:cNvPicPr>
+            <a:picLocks noChangeAspect="1"/>
+          </p:cNvPicPr>
+          <p:nvPr/>
+        </p:nvPicPr>
+        <p:blipFill>
+          <a:blip r:embed="rId2"/>
+          <a:stretch>
+            <a:fillRect/>
+          </a:stretch>
+        </p:blipFill>
+        <p:spPr>
+          <a:xfrm>
+            <a:off x="2937794" y="1152000"/>
+            <a:ext cx="6318000" cy="4860000"/>
+          </a:xfrm>
+          <a:prstGeom prst="rect">
+            <a:avLst/>
+          </a:prstGeom>
+        </p:spPr>
+      </p:pic>
+      <p:sp>
+        <p:nvSpPr>
+          <p:cNvPr id="6" name="TextBox 5"/>
+          <p:cNvSpPr txBox="1"/>
+          <p:nvPr/>
+        </p:nvSpPr>
+        <p:spPr>
+          <a:xfrm>
+            <a:off x="503999" y="6120000"/>
+            <a:ext cx="11185200" cy="432000"/>
+          </a:xfrm>
+          <a:prstGeom prst="rect">
+            <a:avLst/>
+          </a:prstGeom>
+          <a:noFill/>
+        </p:spPr>
+        <p:txBody>
+          <a:bodyPr wrap="square">
+            <a:spAutoFit/>
+          </a:bodyPr>
+          <a:lstStyle/>
+          <a:p>
+            <a:pPr algn="ctr"/>
+            <a:r>
+              <a:rPr sz="1300" b="0" i="1">
+                <a:solidFill>
+                  <a:srgbClr val="6B7280"/>
+                </a:solidFill>
+                <a:latin typeface="Calibri"/>
+              </a:rPr>
+              <a:t>Bedarfsgemeinschaften und Personen in BG korrelieren mit r ≈ 0,95 sehr stark positiv.</a:t>
+            </a:r>
+          </a:p>
+        </p:txBody>
+      </p:sp>
+    </p:spTree>
+  </p:cSld>
+  <p:clrMapOvr>
+    <a:masterClrMapping/>
+  </p:clrMapOvr>
+</p:sld>
+</file>
+
+<file path=ppt/slides/slide21.xml><?xml version="1.0" encoding="utf-8"?>
+<p:sld xmlns:a="http://schemas.openxmlformats.org/drawingml/2006/main" xmlns:p="http://schemas.openxmlformats.org/presentationml/2006/main" xmlns:r="http://schemas.openxmlformats.org/officeDocument/2006/relationships">
+  <p:cSld>
+    <p:spTree>
+      <p:nvGrpSpPr>
+        <p:cNvPr id="1" name=""/>
+        <p:cNvGrpSpPr/>
+        <p:nvPr/>
+      </p:nvGrpSpPr>
+      <p:grpSpPr/>
+      <p:sp>
+        <p:nvSpPr>
+          <p:cNvPr id="2" name="Rectangle 1"/>
+          <p:cNvSpPr/>
+          <p:nvPr/>
+        </p:nvSpPr>
+        <p:spPr>
+          <a:xfrm>
+            <a:off x="0" y="0"/>
+            <a:ext cx="12193588" cy="936000"/>
+          </a:xfrm>
+          <a:prstGeom prst="rect">
+            <a:avLst/>
+          </a:prstGeom>
+          <a:solidFill>
+            <a:srgbClr val="7C3AED"/>
+          </a:solidFill>
+          <a:ln>
+            <a:noFill/>
+          </a:ln>
+          <a:effectLst/>
+        </p:spPr>
+        <p:style>
+          <a:lnRef idx="1">
+            <a:schemeClr val="accent1"/>
+          </a:lnRef>
+          <a:fillRef idx="3">
+            <a:schemeClr val="accent1"/>
+          </a:fillRef>
+          <a:effectRef idx="2">
+            <a:schemeClr val="accent1"/>
+          </a:effectRef>
+          <a:fontRef idx="minor">
+            <a:schemeClr val="lt1"/>
+          </a:fontRef>
+        </p:style>
+        <p:txBody>
+          <a:bodyPr rtlCol="0" anchor="ctr"/>
+          <a:lstStyle/>
+          <a:p>
+            <a:pPr algn="ctr"/>
+          </a:p>
+        </p:txBody>
+      </p:sp>
+      <p:sp>
+        <p:nvSpPr>
+          <p:cNvPr id="3" name="TextBox 2"/>
+          <p:cNvSpPr txBox="1"/>
+          <p:nvPr/>
+        </p:nvSpPr>
+        <p:spPr>
+          <a:xfrm>
+            <a:off x="432000" y="90000"/>
+            <a:ext cx="11329200" cy="251999"/>
+          </a:xfrm>
+          <a:prstGeom prst="rect">
+            <a:avLst/>
+          </a:prstGeom>
+          <a:noFill/>
+        </p:spPr>
+        <p:txBody>
+          <a:bodyPr wrap="square">
+            <a:spAutoFit/>
+          </a:bodyPr>
+          <a:lstStyle/>
+          <a:p>
+            <a:r>
+              <a:rPr sz="1400" b="1" i="0">
+                <a:solidFill>
+                  <a:srgbClr val="FFFFFF"/>
+                </a:solidFill>
+                <a:latin typeface="Calibri"/>
+              </a:rPr>
+              <a:t>4.2</a:t>
+            </a:r>
+          </a:p>
+        </p:txBody>
+      </p:sp>
+      <p:sp>
+        <p:nvSpPr>
+          <p:cNvPr id="4" name="TextBox 3"/>
+          <p:cNvSpPr txBox="1"/>
+          <p:nvPr/>
+        </p:nvSpPr>
+        <p:spPr>
+          <a:xfrm>
+            <a:off x="432000" y="306000"/>
+            <a:ext cx="11329200" cy="540000"/>
+          </a:xfrm>
+          <a:prstGeom prst="rect">
+            <a:avLst/>
+          </a:prstGeom>
+          <a:noFill/>
+        </p:spPr>
+        <p:txBody>
+          <a:bodyPr wrap="square">
+            <a:spAutoFit/>
+          </a:bodyPr>
+          <a:lstStyle/>
+          <a:p>
+            <a:r>
+              <a:rPr sz="2800" b="1" i="0">
+                <a:solidFill>
+                  <a:srgbClr val="FFFFFF"/>
+                </a:solidFill>
+                <a:latin typeface="Calibri"/>
+              </a:rPr>
+              <a:t>Langzeitarbeitslose vs. Bedarfsgemeinschaften</a:t>
+            </a:r>
+          </a:p>
+        </p:txBody>
+      </p:sp>
+      <p:pic>
+        <p:nvPicPr>
+          <p:cNvPr id="5" name="Picture 4" descr="abb7_streudiagramm.png"/>
+          <p:cNvPicPr>
+            <a:picLocks noChangeAspect="1"/>
+          </p:cNvPicPr>
+          <p:nvPr/>
+        </p:nvPicPr>
+        <p:blipFill>
+          <a:blip r:embed="rId2"/>
+          <a:stretch>
+            <a:fillRect/>
+          </a:stretch>
+        </p:blipFill>
+        <p:spPr>
+          <a:xfrm>
+            <a:off x="1236794" y="1152000"/>
+            <a:ext cx="9720000" cy="4860000"/>
+          </a:xfrm>
+          <a:prstGeom prst="rect">
+            <a:avLst/>
+          </a:prstGeom>
+        </p:spPr>
+      </p:pic>
+      <p:sp>
+        <p:nvSpPr>
+          <p:cNvPr id="6" name="TextBox 5"/>
+          <p:cNvSpPr txBox="1"/>
+          <p:nvPr/>
+        </p:nvSpPr>
+        <p:spPr>
+          <a:xfrm>
+            <a:off x="503999" y="6120000"/>
+            <a:ext cx="11185200" cy="432000"/>
+          </a:xfrm>
+          <a:prstGeom prst="rect">
+            <a:avLst/>
+          </a:prstGeom>
+          <a:noFill/>
+        </p:spPr>
+        <p:txBody>
+          <a:bodyPr wrap="square">
+            <a:spAutoFit/>
+          </a:bodyPr>
+          <a:lstStyle/>
+          <a:p>
+            <a:pPr algn="ctr"/>
+            <a:r>
+              <a:rPr sz="1300" b="0" i="1">
+                <a:solidFill>
+                  <a:srgbClr val="6B7280"/>
+                </a:solidFill>
+                <a:latin typeface="Calibri"/>
+              </a:rPr>
+              <a:t>r = −0,49, p = 0,04 — jetzt signifikant (mit 15 Monaten: r = −0,08, p = 0,78, noch nicht nachweisbar).</a:t>
+            </a:r>
+          </a:p>
+        </p:txBody>
+      </p:sp>
+    </p:spTree>
+  </p:cSld>
+  <p:clrMapOvr>
+    <a:masterClrMapping/>
+  </p:clrMapOvr>
+</p:sld>
+</file>
+
+<file path=ppt/slides/slide22.xml><?xml version="1.0" encoding="utf-8"?>
+<p:sld xmlns:a="http://schemas.openxmlformats.org/drawingml/2006/main" xmlns:p="http://schemas.openxmlformats.org/presentationml/2006/main" xmlns:r="http://schemas.openxmlformats.org/officeDocument/2006/relationships">
+  <p:cSld>
+    <p:spTree>
+      <p:nvGrpSpPr>
+        <p:cNvPr id="1" name=""/>
+        <p:cNvGrpSpPr/>
+        <p:nvPr/>
+      </p:nvGrpSpPr>
+      <p:grpSpPr/>
+      <p:sp>
+        <p:nvSpPr>
+          <p:cNvPr id="2" name="Rectangle 1"/>
+          <p:cNvSpPr/>
+          <p:nvPr/>
+        </p:nvSpPr>
+        <p:spPr>
+          <a:xfrm>
+            <a:off x="0" y="0"/>
+            <a:ext cx="12193588" cy="936000"/>
+          </a:xfrm>
+          <a:prstGeom prst="rect">
+            <a:avLst/>
+          </a:prstGeom>
+          <a:solidFill>
+            <a:srgbClr val="F59E0B"/>
+          </a:solidFill>
+          <a:ln>
+            <a:noFill/>
+          </a:ln>
+          <a:effectLst/>
+        </p:spPr>
+        <p:style>
+          <a:lnRef idx="1">
+            <a:schemeClr val="accent1"/>
+          </a:lnRef>
+          <a:fillRef idx="3">
+            <a:schemeClr val="accent1"/>
+          </a:fillRef>
+          <a:effectRef idx="2">
+            <a:schemeClr val="accent1"/>
+          </a:effectRef>
+          <a:fontRef idx="minor">
+            <a:schemeClr val="lt1"/>
+          </a:fontRef>
+        </p:style>
+        <p:txBody>
+          <a:bodyPr rtlCol="0" anchor="ctr"/>
+          <a:lstStyle/>
+          <a:p>
+            <a:pPr algn="ctr"/>
+          </a:p>
+        </p:txBody>
+      </p:sp>
+      <p:sp>
+        <p:nvSpPr>
+          <p:cNvPr id="3" name="TextBox 2"/>
+          <p:cNvSpPr txBox="1"/>
+          <p:nvPr/>
+        </p:nvSpPr>
+        <p:spPr>
+          <a:xfrm>
+            <a:off x="432000" y="90000"/>
+            <a:ext cx="11329200" cy="251999"/>
+          </a:xfrm>
+          <a:prstGeom prst="rect">
+            <a:avLst/>
+          </a:prstGeom>
+          <a:noFill/>
+        </p:spPr>
+        <p:txBody>
+          <a:bodyPr wrap="square">
+            <a:spAutoFit/>
+          </a:bodyPr>
+          <a:lstStyle/>
+          <a:p>
+            <a:r>
+              <a:rPr sz="1400" b="1" i="0">
+                <a:solidFill>
+                  <a:srgbClr val="FFFFFF"/>
+                </a:solidFill>
+                <a:latin typeface="Calibri"/>
+              </a:rPr>
+              <a:t>4.3</a:t>
+            </a:r>
+          </a:p>
+        </p:txBody>
+      </p:sp>
+      <p:sp>
+        <p:nvSpPr>
+          <p:cNvPr id="4" name="TextBox 3"/>
+          <p:cNvSpPr txBox="1"/>
+          <p:nvPr/>
+        </p:nvSpPr>
+        <p:spPr>
+          <a:xfrm>
+            <a:off x="432000" y="306000"/>
+            <a:ext cx="11329200" cy="540000"/>
+          </a:xfrm>
+          <a:prstGeom prst="rect">
+            <a:avLst/>
+          </a:prstGeom>
+          <a:noFill/>
+        </p:spPr>
+        <p:txBody>
+          <a:bodyPr wrap="square">
+            <a:spAutoFit/>
+          </a:bodyPr>
+          <a:lstStyle/>
+          <a:p>
+            <a:r>
+              <a:rPr sz="2800" b="1" i="0">
+                <a:solidFill>
+                  <a:srgbClr val="FFFFFF"/>
+                </a:solidFill>
+                <a:latin typeface="Calibri"/>
+              </a:rPr>
+              <a:t>Verteilungen: Arbeitslose (Bestand)</a:t>
+            </a:r>
+          </a:p>
+        </p:txBody>
+      </p:sp>
+      <p:pic>
+        <p:nvPicPr>
+          <p:cNvPr id="5" name="Picture 4" descr="abb8_verteilung.png"/>
+          <p:cNvPicPr>
+            <a:picLocks noChangeAspect="1"/>
+          </p:cNvPicPr>
+          <p:nvPr/>
+        </p:nvPicPr>
+        <p:blipFill>
+          <a:blip r:embed="rId2"/>
+          <a:stretch>
+            <a:fillRect/>
+          </a:stretch>
+        </p:blipFill>
+        <p:spPr>
+          <a:xfrm>
+            <a:off x="720193" y="1152000"/>
+            <a:ext cx="10753200" cy="4754046"/>
+          </a:xfrm>
+          <a:prstGeom prst="rect">
+            <a:avLst/>
+          </a:prstGeom>
+        </p:spPr>
+      </p:pic>
+      <p:sp>
+        <p:nvSpPr>
+          <p:cNvPr id="6" name="TextBox 5"/>
+          <p:cNvSpPr txBox="1"/>
+          <p:nvPr/>
+        </p:nvSpPr>
+        <p:spPr>
+          <a:xfrm>
+            <a:off x="503999" y="6014046"/>
+            <a:ext cx="11185200" cy="432000"/>
+          </a:xfrm>
+          <a:prstGeom prst="rect">
+            <a:avLst/>
+          </a:prstGeom>
+          <a:noFill/>
+        </p:spPr>
+        <p:txBody>
+          <a:bodyPr wrap="square">
+            <a:spAutoFit/>
+          </a:bodyPr>
+          <a:lstStyle/>
+          <a:p>
+            <a:pPr algn="ctr"/>
+            <a:r>
+              <a:rPr sz="1300" b="0" i="1">
+                <a:solidFill>
+                  <a:srgbClr val="6B7280"/>
+                </a:solidFill>
+                <a:latin typeface="Calibri"/>
+              </a:rPr>
+              <a:t>Keine auffälligen Ausreißer; leicht linksschiefe Verteilung, Median knapp über dem Mittelwert.</a:t>
+            </a:r>
+          </a:p>
+        </p:txBody>
+      </p:sp>
+    </p:spTree>
+  </p:cSld>
+  <p:clrMapOvr>
+    <a:masterClrMapping/>
+  </p:clrMapOvr>
+</p:sld>
+</file>
+
+<file path=ppt/slides/slide23.xml><?xml version="1.0" encoding="utf-8"?>
+<p:sld xmlns:a="http://schemas.openxmlformats.org/drawingml/2006/main" xmlns:p="http://schemas.openxmlformats.org/presentationml/2006/main" xmlns:r="http://schemas.openxmlformats.org/officeDocument/2006/relationships">
+  <p:cSld>
+    <p:spTree>
+      <p:nvGrpSpPr>
+        <p:cNvPr id="1" name=""/>
+        <p:cNvGrpSpPr/>
+        <p:nvPr/>
+      </p:nvGrpSpPr>
+      <p:grpSpPr/>
+      <p:sp>
+        <p:nvSpPr>
+          <p:cNvPr id="2" name="Rectangle 1"/>
+          <p:cNvSpPr/>
+          <p:nvPr/>
+        </p:nvSpPr>
+        <p:spPr>
+          <a:xfrm>
+            <a:off x="0" y="0"/>
+            <a:ext cx="12193588" cy="936000"/>
+          </a:xfrm>
+          <a:prstGeom prst="rect">
+            <a:avLst/>
+          </a:prstGeom>
+          <a:solidFill>
+            <a:srgbClr val="F59E0B"/>
+          </a:solidFill>
+          <a:ln>
+            <a:noFill/>
+          </a:ln>
+          <a:effectLst/>
+        </p:spPr>
+        <p:style>
+          <a:lnRef idx="1">
+            <a:schemeClr val="accent1"/>
+          </a:lnRef>
+          <a:fillRef idx="3">
+            <a:schemeClr val="accent1"/>
+          </a:fillRef>
+          <a:effectRef idx="2">
+            <a:schemeClr val="accent1"/>
+          </a:effectRef>
+          <a:fontRef idx="minor">
+            <a:schemeClr val="lt1"/>
+          </a:fontRef>
+        </p:style>
+        <p:txBody>
+          <a:bodyPr rtlCol="0" anchor="ctr"/>
+          <a:lstStyle/>
+          <a:p>
+            <a:pPr algn="ctr"/>
+          </a:p>
+        </p:txBody>
+      </p:sp>
+      <p:sp>
+        <p:nvSpPr>
+          <p:cNvPr id="3" name="TextBox 2"/>
+          <p:cNvSpPr txBox="1"/>
+          <p:nvPr/>
+        </p:nvSpPr>
+        <p:spPr>
+          <a:xfrm>
+            <a:off x="432000" y="90000"/>
+            <a:ext cx="11329200" cy="251999"/>
+          </a:xfrm>
+          <a:prstGeom prst="rect">
+            <a:avLst/>
+          </a:prstGeom>
+          <a:noFill/>
+        </p:spPr>
+        <p:txBody>
+          <a:bodyPr wrap="square">
+            <a:spAutoFit/>
+          </a:bodyPr>
+          <a:lstStyle/>
+          <a:p>
+            <a:r>
+              <a:rPr sz="1400" b="1" i="0">
+                <a:solidFill>
+                  <a:srgbClr val="FFFFFF"/>
+                </a:solidFill>
+                <a:latin typeface="Calibri"/>
+              </a:rPr>
+              <a:t>4.4</a:t>
+            </a:r>
+          </a:p>
+        </p:txBody>
+      </p:sp>
+      <p:sp>
+        <p:nvSpPr>
+          <p:cNvPr id="4" name="TextBox 3"/>
+          <p:cNvSpPr txBox="1"/>
+          <p:nvPr/>
+        </p:nvSpPr>
+        <p:spPr>
+          <a:xfrm>
+            <a:off x="432000" y="306000"/>
+            <a:ext cx="11329200" cy="540000"/>
+          </a:xfrm>
+          <a:prstGeom prst="rect">
+            <a:avLst/>
+          </a:prstGeom>
+          <a:noFill/>
+        </p:spPr>
+        <p:txBody>
+          <a:bodyPr wrap="square">
+            <a:spAutoFit/>
+          </a:bodyPr>
+          <a:lstStyle/>
+          <a:p>
+            <a:r>
+              <a:rPr sz="2800" b="1" i="0">
+                <a:solidFill>
+                  <a:srgbClr val="FFFFFF"/>
+                </a:solidFill>
+                <a:latin typeface="Calibri"/>
+              </a:rPr>
+              <a:t>Inferenzstatistik: Hypothesentest</a:t>
+            </a:r>
+          </a:p>
+        </p:txBody>
+      </p:sp>
+      <p:sp>
+        <p:nvSpPr>
+          <p:cNvPr id="5" name="TextBox 4"/>
+          <p:cNvSpPr txBox="1"/>
+          <p:nvPr/>
+        </p:nvSpPr>
+        <p:spPr>
+          <a:xfrm>
+            <a:off x="503999" y="1224000"/>
+            <a:ext cx="11185200" cy="5238000"/>
+          </a:xfrm>
+          <a:prstGeom prst="rect">
+            <a:avLst/>
+          </a:prstGeom>
+          <a:noFill/>
+        </p:spPr>
+        <p:txBody>
+          <a:bodyPr wrap="square">
+            <a:spAutoFit/>
+          </a:bodyPr>
+          <a:lstStyle/>
+          <a:p>
+            <a:pPr>
+              <a:spcAft>
+                <a:spcPts val="1600"/>
+              </a:spcAft>
+            </a:pPr>
+            <a:r>
+              <a:rPr sz="1800" b="0" i="0">
+                <a:solidFill>
+                  <a:srgbClr val="374151"/>
+                </a:solidFill>
+                <a:latin typeface="Calibri"/>
+              </a:rPr>
+              <a:t>●  Fragestellung: Unterscheidet sich die Langzeitarbeitslosigkeit zwischen erster und zweiter Hälfte des Beobachtungszeitraums signifikant?</a:t>
+            </a:r>
+          </a:p>
+          <a:p>
+            <a:pPr>
+              <a:spcAft>
+                <a:spcPts val="1600"/>
+              </a:spcAft>
+            </a:pPr>
+            <a:r>
+              <a:rPr sz="1800" b="0" i="0">
+                <a:solidFill>
+                  <a:srgbClr val="374151"/>
+                </a:solidFill>
+                <a:latin typeface="Calibri"/>
+              </a:rPr>
+              <a:t>●  1. Hälfte (n = 9): Ø 543,3 (± 34,1) — 2. Hälfte (n = 9): Ø 661,1 (± 41,2)</a:t>
+            </a:r>
+          </a:p>
+          <a:p>
+            <a:pPr>
+              <a:spcAft>
+                <a:spcPts val="1600"/>
+              </a:spcAft>
+            </a:pPr>
+            <a:r>
+              <a:rPr sz="1800" b="0" i="0">
+                <a:solidFill>
+                  <a:srgbClr val="374151"/>
+                </a:solidFill>
+                <a:latin typeface="Calibri"/>
+              </a:rPr>
+              <a:t>●  Mittelwertdifferenz: 117,8 Personen (95 %-Konfidenzintervall: [82,8; 152,7])</a:t>
+            </a:r>
+          </a:p>
+          <a:p>
+            <a:pPr>
+              <a:spcAft>
+                <a:spcPts val="1600"/>
+              </a:spcAft>
+            </a:pPr>
+            <a:r>
+              <a:rPr sz="1800" b="0" i="0">
+                <a:solidFill>
+                  <a:srgbClr val="374151"/>
+                </a:solidFill>
+                <a:latin typeface="Calibri"/>
+              </a:rPr>
+              <a:t>●  Welch-t-Test: t = 6,61, p ≈ 0,00001 — statistisch hoch signifikant</a:t>
+            </a:r>
+          </a:p>
+        </p:txBody>
+      </p:sp>
+    </p:spTree>
+  </p:cSld>
+  <p:clrMapOvr>
+    <a:masterClrMapping/>
+  </p:clrMapOvr>
+</p:sld>
+</file>
+
+<file path=ppt/slides/slide24.xml><?xml version="1.0" encoding="utf-8"?>
+<p:sld xmlns:a="http://schemas.openxmlformats.org/drawingml/2006/main" xmlns:p="http://schemas.openxmlformats.org/presentationml/2006/main" xmlns:r="http://schemas.openxmlformats.org/officeDocument/2006/relationships">
+  <p:cSld>
+    <p:spTree>
+      <p:nvGrpSpPr>
+        <p:cNvPr id="1" name=""/>
+        <p:cNvGrpSpPr/>
+        <p:nvPr/>
+      </p:nvGrpSpPr>
+      <p:grpSpPr/>
+      <p:sp>
+        <p:nvSpPr>
+          <p:cNvPr id="2" name="Rectangle 1"/>
+          <p:cNvSpPr/>
+          <p:nvPr/>
+        </p:nvSpPr>
+        <p:spPr>
+          <a:xfrm>
+            <a:off x="0" y="0"/>
+            <a:ext cx="12193588" cy="936000"/>
+          </a:xfrm>
+          <a:prstGeom prst="rect">
+            <a:avLst/>
+          </a:prstGeom>
+          <a:solidFill>
+            <a:srgbClr val="DC2626"/>
+          </a:solidFill>
+          <a:ln>
+            <a:noFill/>
+          </a:ln>
+          <a:effectLst/>
+        </p:spPr>
+        <p:style>
+          <a:lnRef idx="1">
+            <a:schemeClr val="accent1"/>
+          </a:lnRef>
+          <a:fillRef idx="3">
+            <a:schemeClr val="accent1"/>
+          </a:fillRef>
+          <a:effectRef idx="2">
+            <a:schemeClr val="accent1"/>
+          </a:effectRef>
+          <a:fontRef idx="minor">
+            <a:schemeClr val="lt1"/>
+          </a:fontRef>
+        </p:style>
+        <p:txBody>
+          <a:bodyPr rtlCol="0" anchor="ctr"/>
+          <a:lstStyle/>
+          <a:p>
+            <a:pPr algn="ctr"/>
+          </a:p>
+        </p:txBody>
+      </p:sp>
+      <p:sp>
+        <p:nvSpPr>
+          <p:cNvPr id="3" name="TextBox 2"/>
+          <p:cNvSpPr txBox="1"/>
+          <p:nvPr/>
+        </p:nvSpPr>
+        <p:spPr>
+          <a:xfrm>
+            <a:off x="432000" y="90000"/>
+            <a:ext cx="11329200" cy="251999"/>
+          </a:xfrm>
+          <a:prstGeom prst="rect">
+            <a:avLst/>
+          </a:prstGeom>
+          <a:noFill/>
+        </p:spPr>
+        <p:txBody>
+          <a:bodyPr wrap="square">
+            <a:spAutoFit/>
+          </a:bodyPr>
+          <a:lstStyle/>
+          <a:p>
+            <a:r>
+              <a:rPr sz="1400" b="1" i="0">
+                <a:solidFill>
+                  <a:srgbClr val="FFFFFF"/>
+                </a:solidFill>
+                <a:latin typeface="Calibri"/>
+              </a:rPr>
+              <a:t>4.5</a:t>
+            </a:r>
+          </a:p>
+        </p:txBody>
+      </p:sp>
+      <p:sp>
+        <p:nvSpPr>
+          <p:cNvPr id="4" name="TextBox 3"/>
+          <p:cNvSpPr txBox="1"/>
+          <p:nvPr/>
+        </p:nvSpPr>
+        <p:spPr>
+          <a:xfrm>
+            <a:off x="432000" y="306000"/>
+            <a:ext cx="11329200" cy="540000"/>
+          </a:xfrm>
+          <a:prstGeom prst="rect">
+            <a:avLst/>
+          </a:prstGeom>
+          <a:noFill/>
+        </p:spPr>
+        <p:txBody>
+          <a:bodyPr wrap="square">
+            <a:spAutoFit/>
+          </a:bodyPr>
+          <a:lstStyle/>
+          <a:p>
+            <a:r>
+              <a:rPr sz="2800" b="1" i="0">
+                <a:solidFill>
+                  <a:srgbClr val="FFFFFF"/>
+                </a:solidFill>
+                <a:latin typeface="Calibri"/>
+              </a:rPr>
+              <a:t>Regressionsanalyse: Trend der Langzeitarbeitslosigkeit</a:t>
+            </a:r>
+          </a:p>
+        </p:txBody>
+      </p:sp>
+      <p:sp>
+        <p:nvSpPr>
+          <p:cNvPr id="5" name="TextBox 4"/>
+          <p:cNvSpPr txBox="1"/>
+          <p:nvPr/>
+        </p:nvSpPr>
+        <p:spPr>
+          <a:xfrm>
+            <a:off x="503999" y="1224000"/>
+            <a:ext cx="11185200" cy="5238000"/>
+          </a:xfrm>
+          <a:prstGeom prst="rect">
+            <a:avLst/>
+          </a:prstGeom>
+          <a:noFill/>
+        </p:spPr>
+        <p:txBody>
+          <a:bodyPr wrap="square">
+            <a:spAutoFit/>
+          </a:bodyPr>
+          <a:lstStyle/>
+          <a:p>
+            <a:pPr>
+              <a:spcAft>
+                <a:spcPts val="1600"/>
+              </a:spcAft>
+            </a:pPr>
+            <a:r>
+              <a:rPr sz="1800" b="0" i="0">
+                <a:solidFill>
+                  <a:srgbClr val="374151"/>
+                </a:solidFill>
+                <a:latin typeface="Calibri"/>
+              </a:rPr>
+              <a:t>●  Regressionsgleichung: Langzeitarbeitslose = 490,4 + 13,16 × Monatsindex</a:t>
+            </a:r>
+          </a:p>
+          <a:p>
+            <a:pPr>
+              <a:spcAft>
+                <a:spcPts val="1600"/>
+              </a:spcAft>
+            </a:pPr>
+            <a:r>
+              <a:rPr sz="1800" b="0" i="0">
+                <a:solidFill>
+                  <a:srgbClr val="374151"/>
+                </a:solidFill>
+                <a:latin typeface="Calibri"/>
+              </a:rPr>
+              <a:t>●  Steigung: +13,2 Personen pro Monat — Bestimmtheitsmaß R² = 0,983</a:t>
+            </a:r>
+          </a:p>
+          <a:p>
+            <a:pPr>
+              <a:spcAft>
+                <a:spcPts val="1600"/>
+              </a:spcAft>
+            </a:pPr>
+            <a:r>
+              <a:rPr sz="1800" b="0" i="0">
+                <a:solidFill>
+                  <a:srgbClr val="374151"/>
+                </a:solidFill>
+                <a:latin typeface="Calibri"/>
+              </a:rPr>
+              <a:t>●  Prognose: Juli 2026 ≈ 727, August 2026 ≈ 740, September 2026 ≈ 754 Personen</a:t>
+            </a:r>
+          </a:p>
+          <a:p>
+            <a:pPr>
+              <a:spcAft>
+                <a:spcPts val="1600"/>
+              </a:spcAft>
+            </a:pPr>
+            <a:r>
+              <a:rPr sz="1800" b="0" i="0">
+                <a:solidFill>
+                  <a:srgbClr val="374151"/>
+                </a:solidFill>
+                <a:latin typeface="Calibri"/>
+              </a:rPr>
+              <a:t>●  Einschränkung: lineare Extrapolation aus nur 18 Datenpunkten, ohne Saisonalität oder Strukturbrüche</a:t>
+            </a:r>
+          </a:p>
+        </p:txBody>
+      </p:sp>
+    </p:spTree>
+  </p:cSld>
+  <p:clrMapOvr>
+    <a:masterClrMapping/>
+  </p:clrMapOvr>
+</p:sld>
+</file>
+
+<file path=ppt/slides/slide25.xml><?xml version="1.0" encoding="utf-8"?>
+<p:sld xmlns:a="http://schemas.openxmlformats.org/drawingml/2006/main" xmlns:p="http://schemas.openxmlformats.org/presentationml/2006/main" xmlns:r="http://schemas.openxmlformats.org/officeDocument/2006/relationships">
+  <p:cSld>
+    <p:spTree>
+      <p:nvGrpSpPr>
+        <p:cNvPr id="1" name=""/>
+        <p:cNvGrpSpPr/>
+        <p:nvPr/>
+      </p:nvGrpSpPr>
+      <p:grpSpPr/>
+      <p:sp>
+        <p:nvSpPr>
+          <p:cNvPr id="2" name="Rectangle 1"/>
+          <p:cNvSpPr/>
+          <p:nvPr/>
+        </p:nvSpPr>
+        <p:spPr>
+          <a:xfrm>
+            <a:off x="0" y="0"/>
+            <a:ext cx="12193588" cy="936000"/>
+          </a:xfrm>
+          <a:prstGeom prst="rect">
+            <a:avLst/>
+          </a:prstGeom>
+          <a:solidFill>
+            <a:srgbClr val="DC2626"/>
+          </a:solidFill>
+          <a:ln>
+            <a:noFill/>
+          </a:ln>
+          <a:effectLst/>
+        </p:spPr>
+        <p:style>
+          <a:lnRef idx="1">
+            <a:schemeClr val="accent1"/>
+          </a:lnRef>
+          <a:fillRef idx="3">
+            <a:schemeClr val="accent1"/>
+          </a:fillRef>
+          <a:effectRef idx="2">
+            <a:schemeClr val="accent1"/>
+          </a:effectRef>
+          <a:fontRef idx="minor">
+            <a:schemeClr val="lt1"/>
+          </a:fontRef>
+        </p:style>
+        <p:txBody>
+          <a:bodyPr rtlCol="0" anchor="ctr"/>
+          <a:lstStyle/>
+          <a:p>
+            <a:pPr algn="ctr"/>
+          </a:p>
+        </p:txBody>
+      </p:sp>
+      <p:sp>
+        <p:nvSpPr>
+          <p:cNvPr id="3" name="TextBox 2"/>
+          <p:cNvSpPr txBox="1"/>
+          <p:nvPr/>
+        </p:nvSpPr>
+        <p:spPr>
+          <a:xfrm>
+            <a:off x="432000" y="90000"/>
+            <a:ext cx="11329200" cy="251999"/>
+          </a:xfrm>
+          <a:prstGeom prst="rect">
+            <a:avLst/>
+          </a:prstGeom>
+          <a:noFill/>
+        </p:spPr>
+        <p:txBody>
+          <a:bodyPr wrap="square">
+            <a:spAutoFit/>
+          </a:bodyPr>
+          <a:lstStyle/>
+          <a:p>
+            <a:r>
+              <a:rPr sz="1400" b="1" i="0">
+                <a:solidFill>
+                  <a:srgbClr val="FFFFFF"/>
+                </a:solidFill>
+                <a:latin typeface="Calibri"/>
+              </a:rPr>
+              <a:t>4.5</a:t>
+            </a:r>
+          </a:p>
+        </p:txBody>
+      </p:sp>
+      <p:sp>
+        <p:nvSpPr>
+          <p:cNvPr id="4" name="TextBox 3"/>
+          <p:cNvSpPr txBox="1"/>
+          <p:nvPr/>
+        </p:nvSpPr>
+        <p:spPr>
+          <a:xfrm>
+            <a:off x="432000" y="306000"/>
+            <a:ext cx="11329200" cy="540000"/>
+          </a:xfrm>
+          <a:prstGeom prst="rect">
+            <a:avLst/>
+          </a:prstGeom>
+          <a:noFill/>
+        </p:spPr>
+        <p:txBody>
+          <a:bodyPr wrap="square">
+            <a:spAutoFit/>
+          </a:bodyPr>
+          <a:lstStyle/>
+          <a:p>
+            <a:r>
+              <a:rPr sz="2800" b="1" i="0">
+                <a:solidFill>
+                  <a:srgbClr val="FFFFFF"/>
+                </a:solidFill>
+                <a:latin typeface="Calibri"/>
+              </a:rPr>
+              <a:t>Linearer Trend und Prognose</a:t>
+            </a:r>
+          </a:p>
+        </p:txBody>
+      </p:sp>
+      <p:pic>
+        <p:nvPicPr>
+          <p:cNvPr id="5" name="Picture 4" descr="abb9_regression.png"/>
+          <p:cNvPicPr>
+            <a:picLocks noChangeAspect="1"/>
+          </p:cNvPicPr>
+          <p:nvPr/>
+        </p:nvPicPr>
+        <p:blipFill>
+          <a:blip r:embed="rId2"/>
+          <a:stretch>
+            <a:fillRect/>
+          </a:stretch>
+        </p:blipFill>
+        <p:spPr>
+          <a:xfrm>
+            <a:off x="1287419" y="1152000"/>
+            <a:ext cx="9618750" cy="4860000"/>
+          </a:xfrm>
+          <a:prstGeom prst="rect">
+            <a:avLst/>
+          </a:prstGeom>
+        </p:spPr>
+      </p:pic>
+      <p:sp>
+        <p:nvSpPr>
+          <p:cNvPr id="6" name="TextBox 5"/>
+          <p:cNvSpPr txBox="1"/>
+          <p:nvPr/>
+        </p:nvSpPr>
+        <p:spPr>
+          <a:xfrm>
+            <a:off x="503999" y="6120000"/>
+            <a:ext cx="11185200" cy="432000"/>
+          </a:xfrm>
+          <a:prstGeom prst="rect">
+            <a:avLst/>
+          </a:prstGeom>
+          <a:noFill/>
+        </p:spPr>
+        <p:txBody>
+          <a:bodyPr wrap="square">
+            <a:spAutoFit/>
+          </a:bodyPr>
+          <a:lstStyle/>
+          <a:p>
+            <a:pPr algn="ctr"/>
+            <a:r>
+              <a:rPr sz="1300" b="0" i="1">
+                <a:solidFill>
+                  <a:srgbClr val="6B7280"/>
+                </a:solidFill>
+                <a:latin typeface="Calibri"/>
+              </a:rPr>
+              <a:t>R² = 0,983 — ein außergewöhnlich guter linearer Fit für die Langzeitarbeitslosen-Zahl.</a:t>
+            </a:r>
+          </a:p>
+        </p:txBody>
+      </p:sp>
+    </p:spTree>
+  </p:cSld>
+  <p:clrMapOvr>
+    <a:masterClrMapping/>
+  </p:clrMapOvr>
+</p:sld>
+</file>
+
+<file path=ppt/slides/slide26.xml><?xml version="1.0" encoding="utf-8"?>
+<p:sld xmlns:a="http://schemas.openxmlformats.org/drawingml/2006/main" xmlns:p="http://schemas.openxmlformats.org/presentationml/2006/main" xmlns:r="http://schemas.openxmlformats.org/officeDocument/2006/relationships">
+  <p:cSld>
+    <p:spTree>
+      <p:nvGrpSpPr>
+        <p:cNvPr id="1" name=""/>
+        <p:cNvGrpSpPr/>
+        <p:nvPr/>
+      </p:nvGrpSpPr>
+      <p:grpSpPr/>
+      <p:sp>
+        <p:nvSpPr>
+          <p:cNvPr id="2" name="Rectangle 1"/>
+          <p:cNvSpPr/>
+          <p:nvPr/>
+        </p:nvSpPr>
+        <p:spPr>
+          <a:xfrm>
+            <a:off x="0" y="0"/>
+            <a:ext cx="12193588" cy="936000"/>
+          </a:xfrm>
+          <a:prstGeom prst="rect">
+            <a:avLst/>
+          </a:prstGeom>
+          <a:solidFill>
+            <a:srgbClr val="0D9488"/>
+          </a:solidFill>
+          <a:ln>
+            <a:noFill/>
+          </a:ln>
+          <a:effectLst/>
+        </p:spPr>
+        <p:style>
+          <a:lnRef idx="1">
+            <a:schemeClr val="accent1"/>
+          </a:lnRef>
+          <a:fillRef idx="3">
+            <a:schemeClr val="accent1"/>
+          </a:fillRef>
+          <a:effectRef idx="2">
+            <a:schemeClr val="accent1"/>
+          </a:effectRef>
+          <a:fontRef idx="minor">
+            <a:schemeClr val="lt1"/>
+          </a:fontRef>
+        </p:style>
+        <p:txBody>
+          <a:bodyPr rtlCol="0" anchor="ctr"/>
+          <a:lstStyle/>
+          <a:p>
+            <a:pPr algn="ctr"/>
+          </a:p>
+        </p:txBody>
+      </p:sp>
+      <p:sp>
+        <p:nvSpPr>
+          <p:cNvPr id="3" name="TextBox 2"/>
+          <p:cNvSpPr txBox="1"/>
+          <p:nvPr/>
+        </p:nvSpPr>
+        <p:spPr>
+          <a:xfrm>
+            <a:off x="432000" y="90000"/>
+            <a:ext cx="11329200" cy="251999"/>
+          </a:xfrm>
+          <a:prstGeom prst="rect">
+            <a:avLst/>
+          </a:prstGeom>
+          <a:noFill/>
+        </p:spPr>
+        <p:txBody>
+          <a:bodyPr wrap="square">
+            <a:spAutoFit/>
+          </a:bodyPr>
+          <a:lstStyle/>
+          <a:p>
+            <a:r>
+              <a:rPr sz="1400" b="1" i="0">
+                <a:solidFill>
+                  <a:srgbClr val="FFFFFF"/>
+                </a:solidFill>
+                <a:latin typeface="Calibri"/>
+              </a:rPr>
+              <a:t>4.6</a:t>
+            </a:r>
+          </a:p>
+        </p:txBody>
+      </p:sp>
+      <p:sp>
+        <p:nvSpPr>
+          <p:cNvPr id="4" name="TextBox 3"/>
+          <p:cNvSpPr txBox="1"/>
+          <p:nvPr/>
+        </p:nvSpPr>
+        <p:spPr>
+          <a:xfrm>
+            <a:off x="432000" y="306000"/>
+            <a:ext cx="11329200" cy="540000"/>
+          </a:xfrm>
+          <a:prstGeom prst="rect">
+            <a:avLst/>
+          </a:prstGeom>
+          <a:noFill/>
+        </p:spPr>
+        <p:txBody>
+          <a:bodyPr wrap="square">
+            <a:spAutoFit/>
+          </a:bodyPr>
+          <a:lstStyle/>
+          <a:p>
+            <a:r>
+              <a:rPr sz="2800" b="1" i="0">
+                <a:solidFill>
+                  <a:srgbClr val="FFFFFF"/>
+                </a:solidFill>
+                <a:latin typeface="Calibri"/>
+              </a:rPr>
+              <a:t>Zusammenfassung der statistischen Befunde</a:t>
+            </a:r>
+          </a:p>
+        </p:txBody>
+      </p:sp>
+      <p:sp>
+        <p:nvSpPr>
+          <p:cNvPr id="5" name="TextBox 4"/>
+          <p:cNvSpPr txBox="1"/>
+          <p:nvPr/>
+        </p:nvSpPr>
+        <p:spPr>
+          <a:xfrm>
+            <a:off x="503999" y="1224000"/>
+            <a:ext cx="11185200" cy="5238000"/>
+          </a:xfrm>
+          <a:prstGeom prst="rect">
+            <a:avLst/>
+          </a:prstGeom>
+          <a:noFill/>
+        </p:spPr>
+        <p:txBody>
+          <a:bodyPr wrap="square">
+            <a:spAutoFit/>
+          </a:bodyPr>
+          <a:lstStyle/>
+          <a:p>
+            <a:pPr>
+              <a:spcAft>
+                <a:spcPts val="1600"/>
+              </a:spcAft>
+            </a:pPr>
+            <a:r>
+              <a:rPr sz="1800" b="0" i="0">
+                <a:solidFill>
+                  <a:srgbClr val="374151"/>
+                </a:solidFill>
+                <a:latin typeface="Calibri"/>
+              </a:rPr>
+              <a:t>●  Langzeitarbeitslose: stärkste relative Veränderung (CV ≈ 11,8 %) aller Kernkennzahlen</a:t>
+            </a:r>
+          </a:p>
+          <a:p>
+            <a:pPr>
+              <a:spcAft>
+                <a:spcPts val="1600"/>
+              </a:spcAft>
+            </a:pPr>
+            <a:r>
+              <a:rPr sz="1800" b="0" i="0">
+                <a:solidFill>
+                  <a:srgbClr val="374151"/>
+                </a:solidFill>
+                <a:latin typeface="Calibri"/>
+              </a:rPr>
+              <a:t>●  Zwei zuvor nicht signifikante Korrelationen wurden durch die 3 zusätzlichen Monate erst nachweisbar (LZA–Bedarfsgemeinschaften, LZA–Bestand)</a:t>
+            </a:r>
+          </a:p>
+          <a:p>
+            <a:pPr>
+              <a:spcAft>
+                <a:spcPts val="1600"/>
+              </a:spcAft>
+            </a:pPr>
+            <a:r>
+              <a:rPr sz="1800" b="0" i="0">
+                <a:solidFill>
+                  <a:srgbClr val="374151"/>
+                </a:solidFill>
+                <a:latin typeface="Calibri"/>
+              </a:rPr>
+              <a:t>●  Anstieg der Langzeitarbeitslosigkeit zwischen erster und zweiter Hälfte: statistisch hoch signifikant (p ≈ 0,00001)</a:t>
+            </a:r>
+          </a:p>
+          <a:p>
+            <a:pPr>
+              <a:spcAft>
+                <a:spcPts val="1600"/>
+              </a:spcAft>
+            </a:pPr>
+            <a:r>
+              <a:rPr sz="1800" b="0" i="0">
+                <a:solidFill>
+                  <a:srgbClr val="374151"/>
+                </a:solidFill>
+                <a:latin typeface="Calibri"/>
+              </a:rPr>
+              <a:t>●  Linearer Zeittrend erklärt 98,3 % der Schwankung — Prognose: weiterer Anstieg auf rund 727–754 Personen</a:t>
+            </a:r>
+          </a:p>
+        </p:txBody>
+      </p:sp>
+    </p:spTree>
+  </p:cSld>
+  <p:clrMapOvr>
+    <a:masterClrMapping/>
+  </p:clrMapOvr>
+</p:sld>
+</file>
+
+<file path=ppt/slides/slide27.xml><?xml version="1.0" encoding="utf-8"?>
+<p:sld xmlns:a="http://schemas.openxmlformats.org/drawingml/2006/main" xmlns:r="http://schemas.openxmlformats.org/officeDocument/2006/relationships" xmlns:p="http://schemas.openxmlformats.org/presentationml/2006/main">
+  <p:cSld>
+    <p:bg>
+      <p:bgPr>
+        <a:solidFill>
+          <a:srgbClr val="DC2626"/>
+        </a:solidFill>
+        <a:effectLst/>
+      </p:bgPr>
+    </p:bg>
+    <p:spTree>
+      <p:nvGrpSpPr>
+        <p:cNvPr id="1" name=""/>
+        <p:cNvGrpSpPr/>
+        <p:nvPr/>
+      </p:nvGrpSpPr>
+      <p:grpSpPr>
+        <a:xfrm>
+          <a:off x="0" y="0"/>
+          <a:ext cx="0" cy="0"/>
+          <a:chOff x="0" y="0"/>
+          <a:chExt cx="0" cy="0"/>
+        </a:xfrm>
+      </p:grpSpPr>
+      <p:sp>
+        <p:nvSpPr>
+          <p:cNvPr id="2" name="Rectangle 1"/>
+          <p:cNvSpPr/>
+          <p:nvPr/>
+        </p:nvSpPr>
+        <p:spPr>
+          <a:xfrm>
+            <a:off x="0" y="2951999"/>
+            <a:ext cx="12193200" cy="54000"/>
+          </a:xfrm>
+          <a:prstGeom prst="rect">
+            <a:avLst/>
+          </a:prstGeom>
+          <a:solidFill>
+            <a:srgbClr val="F59E0B"/>
+          </a:solidFill>
+          <a:ln>
+            <a:noFill/>
+          </a:ln>
+          <a:effectLst/>
+        </p:spPr>
+        <p:style>
+          <a:lnRef idx="1">
+            <a:schemeClr val="accent1"/>
+          </a:lnRef>
+          <a:fillRef idx="3">
+            <a:schemeClr val="accent1"/>
+          </a:fillRef>
+          <a:effectRef idx="2">
+            <a:schemeClr val="accent1"/>
+          </a:effectRef>
+          <a:fontRef idx="minor">
+            <a:schemeClr val="lt1"/>
+          </a:fontRef>
+        </p:style>
+        <p:txBody>
+          <a:bodyPr rtlCol="0" anchor="ctr"/>
+          <a:lstStyle/>
+          <a:p>
+            <a:pPr algn="ctr"/>
+            <a:endParaRPr/>
+          </a:p>
+        </p:txBody>
+      </p:sp>
+      <p:sp>
+        <p:nvSpPr>
+          <p:cNvPr id="3" name="TextBox 2"/>
+          <p:cNvSpPr txBox="1"/>
+          <p:nvPr/>
+        </p:nvSpPr>
+        <p:spPr>
+          <a:xfrm>
+            <a:off x="720000" y="1944000"/>
+            <a:ext cx="10753200" cy="540000"/>
+          </a:xfrm>
+          <a:prstGeom prst="rect">
+            <a:avLst/>
+          </a:prstGeom>
+          <a:noFill/>
+        </p:spPr>
+        <p:txBody>
+          <a:bodyPr wrap="square" anchor="t">
+            <a:spAutoFit/>
+          </a:bodyPr>
+          <a:lstStyle/>
+          <a:p>
+            <a:pPr algn="l"/>
+            <a:r>
+              <a:rPr sz="2200" b="1" i="0">
+                <a:solidFill>
+                  <a:srgbClr val="BFDBFE"/>
+                </a:solidFill>
+                <a:latin typeface="Calibri"/>
+              </a:rPr>
+              <a:t>KAPITEL 5</a:t>
+            </a:r>
+          </a:p>
+        </p:txBody>
+      </p:sp>
+      <p:sp>
+        <p:nvSpPr>
+          <p:cNvPr id="4" name="TextBox 3"/>
+          <p:cNvSpPr txBox="1"/>
+          <p:nvPr/>
+        </p:nvSpPr>
+        <p:spPr>
+          <a:xfrm>
+            <a:off x="720000" y="2196000"/>
+            <a:ext cx="10753200" cy="792000"/>
+          </a:xfrm>
+          <a:prstGeom prst="rect">
+            <a:avLst/>
+          </a:prstGeom>
+          <a:noFill/>
+        </p:spPr>
+        <p:txBody>
+          <a:bodyPr wrap="square" anchor="t">
+            <a:spAutoFit/>
+          </a:bodyPr>
+          <a:lstStyle/>
+          <a:p>
+            <a:pPr algn="l"/>
+            <a:r>
+              <a:rPr sz="4000" b="1" i="0">
+                <a:solidFill>
+                  <a:srgbClr val="FFFFFF"/>
+                </a:solidFill>
+                <a:latin typeface="Calibri"/>
+              </a:rPr>
+              <a:t>Fazit und Ausblick</a:t>
+            </a:r>
+          </a:p>
+        </p:txBody>
+      </p:sp>
+      <p:sp>
+        <p:nvSpPr>
+          <p:cNvPr id="5" name="TextBox 4"/>
+          <p:cNvSpPr txBox="1"/>
+          <p:nvPr/>
+        </p:nvSpPr>
+        <p:spPr>
+          <a:xfrm>
+            <a:off x="720000" y="3311999"/>
+            <a:ext cx="10753200" cy="2880000"/>
+          </a:xfrm>
+          <a:prstGeom prst="rect">
+            <a:avLst/>
+          </a:prstGeom>
+          <a:noFill/>
+        </p:spPr>
+        <p:txBody>
+          <a:bodyPr wrap="square">
+            <a:spAutoFit/>
+          </a:bodyPr>
+          <a:lstStyle/>
+          <a:p>
+            <a:pPr>
+              <a:spcAft>
+                <a:spcPts val="1200"/>
+              </a:spcAft>
+            </a:pPr>
+            <a:r>
+              <a:rPr sz="1800">
+                <a:solidFill>
+                  <a:srgbClr val="E0E7FF"/>
+                </a:solidFill>
+                <a:latin typeface="Calibri"/>
+              </a:rPr>
+              <a:t>●  Zusammenfassung der Projektergebnisse</a:t>
+            </a:r>
+          </a:p>
+          <a:p>
+            <a:pPr>
+              <a:spcAft>
+                <a:spcPts val="1200"/>
+              </a:spcAft>
+            </a:pPr>
+            <a:r>
+              <a:rPr sz="1800">
+                <a:solidFill>
+                  <a:srgbClr val="E0E7FF"/>
+                </a:solidFill>
+                <a:latin typeface="Calibri"/>
+              </a:rPr>
+              <a:t>●  Priorisierte Themen für die Fortsetzung</a:t>
+            </a:r>
+          </a:p>
+        </p:txBody>
+      </p:sp>
+    </p:spTree>
+  </p:cSld>
+  <p:clrMapOvr>
+    <a:masterClrMapping/>
+  </p:clrMapOvr>
+</p:sld>
+</file>
+
+<file path=ppt/slides/slide28.xml><?xml version="1.0" encoding="utf-8"?>
 <p:sld xmlns:a="http://schemas.openxmlformats.org/drawingml/2006/main" xmlns:r="http://schemas.openxmlformats.org/officeDocument/2006/relationships" xmlns:p="http://schemas.openxmlformats.org/presentationml/2006/main">
   <p:cSld>
     <p:bg>
@@ -6473,7 +8209,7 @@
                 </a:solidFill>
                 <a:latin typeface="Calibri"/>
               </a:rPr>
-              <a:t>4.2</a:t>
+              <a:t>5.1</a:t>
             </a:r>
           </a:p>
         </p:txBody>
@@ -6508,7 +8244,7 @@
                 </a:solidFill>
                 <a:latin typeface="Calibri"/>
               </a:rPr>
-              <a:t>Ausblick — priorisierte nächste Schritte</a:t>
+              <a:t>Fazit</a:t>
             </a:r>
           </a:p>
         </p:txBody>
@@ -6547,7 +8283,7 @@
                 </a:solidFill>
                 <a:latin typeface="Calibri"/>
               </a:rPr>
-              <a:t>●  1. Fluktuation (Zugang/Abgang) — direkt verfügbar, kein Zusatzaufwand.</a:t>
+              <a:t>●  Aus 18 Excel-Berichten mit über 20 Tabellenblättern wurde eine strukturierte Zeitreihe mit 9 zentralen SGB-II-Kennzahlen erstellt.</a:t>
             </a:r>
           </a:p>
           <a:p>
@@ -6563,7 +8299,7 @@
                 </a:solidFill>
                 <a:latin typeface="Calibri"/>
               </a:rPr>
-              <a:t>●  2. Demografie im Zeitverlauf — Alter/Geschlecht als Zeitreihe statt Momentaufnahme.</a:t>
+              <a:t>●  5 interaktive Diagramme sowie eine Kennzahlen-Vergleichstabelle machen die Entwicklung nachvollziehbar.</a:t>
             </a:r>
           </a:p>
           <a:p>
@@ -6579,7 +8315,7 @@
                 </a:solidFill>
                 <a:latin typeface="Calibri"/>
               </a:rPr>
-              <a:t>●  3. Erwerbstätigkeit / „Aufstocker“ — erweitert die Trichter-Logik aus Kapitel 3.1.</a:t>
+              <a:t>●  Ergebnisse zusätzlich in einem öffentlichen Streamlit-Dashboard bereitgestellt.</a:t>
             </a:r>
           </a:p>
           <a:p>
@@ -6595,55 +8331,7 @@
                 </a:solidFill>
                 <a:latin typeface="Calibri"/>
               </a:rPr>
-              <a:t>●  4. Finanzen (Zahlungsansprüche) — einzige Quelle für Euro-Beträge.</a:t>
-            </a:r>
-          </a:p>
-          <a:p>
-            <a:pPr>
-              <a:spcAft>
-                <a:spcPts val="1400"/>
-              </a:spcAft>
-            </a:pPr>
-            <a:r>
-              <a:rPr sz="1800">
-                <a:solidFill>
-                  <a:srgbClr val="374151"/>
-                </a:solidFill>
-                <a:latin typeface="Calibri"/>
-              </a:rPr>
-              <a:t>●  5. Förderung (aktive Arbeitsmarktpolitik) — inkl. Aktivierungsquote.</a:t>
-            </a:r>
-          </a:p>
-          <a:p>
-            <a:pPr>
-              <a:spcAft>
-                <a:spcPts val="1400"/>
-              </a:spcAft>
-            </a:pPr>
-            <a:r>
-              <a:rPr sz="1800">
-                <a:solidFill>
-                  <a:srgbClr val="374151"/>
-                </a:solidFill>
-                <a:latin typeface="Calibri"/>
-              </a:rPr>
-              <a:t>●  Nachrangig: Bezugsdauer (Langzeitleistungsbezug, Drehtür-Effekt, Haushaltsgröße).</a:t>
-            </a:r>
-          </a:p>
-          <a:p>
-            <a:pPr>
-              <a:spcAft>
-                <a:spcPts val="1400"/>
-              </a:spcAft>
-            </a:pPr>
-            <a:r>
-              <a:rPr sz="1800">
-                <a:solidFill>
-                  <a:srgbClr val="374151"/>
-                </a:solidFill>
-                <a:latin typeface="Calibri"/>
-              </a:rPr>
-              <a:t>●  Methodisch offen: Korrelation, Streudiagramme, Histogramm/Boxplot, Regression.</a:t>
+              <a:t>●  Kernbefund: Arbeitslosenbestand/-quote stabil, aber deutliche Verschärfung der Langzeitarbeitslosigkeit — eine Entwicklung, die in den Rohdaten allein kaum erkennbar gewesen wäre.</a:t>
             </a:r>
           </a:p>
         </p:txBody>
@@ -6656,13 +8344,13 @@
 </p:sld>
 </file>
 
-<file path=ppt/slides/slide21.xml><?xml version="1.0" encoding="utf-8"?>
+<file path=ppt/slides/slide29.xml><?xml version="1.0" encoding="utf-8"?>
 <p:sld xmlns:a="http://schemas.openxmlformats.org/drawingml/2006/main" xmlns:r="http://schemas.openxmlformats.org/officeDocument/2006/relationships" xmlns:p="http://schemas.openxmlformats.org/presentationml/2006/main">
   <p:cSld>
     <p:bg>
       <p:bgPr>
         <a:solidFill>
-          <a:srgbClr val="1E3A8A"/>
+          <a:srgbClr val="FFFFFF"/>
         </a:solidFill>
         <a:effectLst/>
       </p:bgPr>
@@ -6689,14 +8377,14 @@
         </p:nvSpPr>
         <p:spPr>
           <a:xfrm>
-            <a:off x="0" y="3240000"/>
-            <a:ext cx="12193200" cy="54000"/>
+            <a:off x="0" y="0"/>
+            <a:ext cx="12193200" cy="936000"/>
           </a:xfrm>
           <a:prstGeom prst="rect">
             <a:avLst/>
           </a:prstGeom>
           <a:solidFill>
-            <a:srgbClr val="F59E0B"/>
+            <a:srgbClr val="DC2626"/>
           </a:solidFill>
           <a:ln>
             <a:noFill/>
@@ -6734,8 +8422,8 @@
         </p:nvSpPr>
         <p:spPr>
           <a:xfrm>
-            <a:off x="720000" y="2484000"/>
-            <a:ext cx="10753200" cy="540000"/>
+            <a:off x="432000" y="90000"/>
+            <a:ext cx="11329200" cy="251999"/>
           </a:xfrm>
           <a:prstGeom prst="rect">
             <a:avLst/>
@@ -6748,15 +8436,15 @@
           </a:bodyPr>
           <a:lstStyle/>
           <a:p>
-            <a:pPr algn="ctr"/>
-            <a:r>
-              <a:rPr sz="3600" b="1" i="0">
+            <a:pPr algn="l"/>
+            <a:r>
+              <a:rPr sz="1400" b="1" i="0">
                 <a:solidFill>
                   <a:srgbClr val="FFFFFF"/>
                 </a:solidFill>
                 <a:latin typeface="Calibri"/>
               </a:rPr>
-              <a:t>Vielen Dank für die Aufmerksamkeit</a:t>
+              <a:t>5.2</a:t>
             </a:r>
           </a:p>
         </p:txBody>
@@ -6769,8 +8457,8 @@
         </p:nvSpPr>
         <p:spPr>
           <a:xfrm>
-            <a:off x="720000" y="3456000"/>
-            <a:ext cx="10753200" cy="360000"/>
+            <a:off x="432000" y="306000"/>
+            <a:ext cx="11329200" cy="540000"/>
           </a:xfrm>
           <a:prstGeom prst="rect">
             <a:avLst/>
@@ -6783,15 +8471,150 @@
           </a:bodyPr>
           <a:lstStyle/>
           <a:p>
-            <a:pPr algn="ctr"/>
-            <a:r>
-              <a:rPr sz="1600" b="0" i="0">
-                <a:solidFill>
-                  <a:srgbClr val="BFDBFE"/>
-                </a:solidFill>
-                <a:latin typeface="Calibri"/>
-              </a:rPr>
-              <a:t>Live-Dashboard: daelwve9mj8pxz32vshq7u.streamlit.app</a:t>
+            <a:pPr algn="l"/>
+            <a:r>
+              <a:rPr sz="2800" b="1" i="0">
+                <a:solidFill>
+                  <a:srgbClr val="FFFFFF"/>
+                </a:solidFill>
+                <a:latin typeface="Calibri"/>
+              </a:rPr>
+              <a:t>Ausblick — priorisierte nächste Schritte</a:t>
+            </a:r>
+          </a:p>
+        </p:txBody>
+      </p:sp>
+      <p:sp>
+        <p:nvSpPr>
+          <p:cNvPr id="5" name="TextBox 4"/>
+          <p:cNvSpPr txBox="1"/>
+          <p:nvPr/>
+        </p:nvSpPr>
+        <p:spPr>
+          <a:xfrm>
+            <a:off x="503999" y="1224000"/>
+            <a:ext cx="11185201" cy="5238000"/>
+          </a:xfrm>
+          <a:prstGeom prst="rect">
+            <a:avLst/>
+          </a:prstGeom>
+          <a:noFill/>
+        </p:spPr>
+        <p:txBody>
+          <a:bodyPr wrap="square">
+            <a:spAutoFit/>
+          </a:bodyPr>
+          <a:lstStyle/>
+          <a:p>
+            <a:pPr>
+              <a:spcAft>
+                <a:spcPts val="1400"/>
+              </a:spcAft>
+            </a:pPr>
+            <a:r>
+              <a:rPr sz="1800">
+                <a:solidFill>
+                  <a:srgbClr val="374151"/>
+                </a:solidFill>
+                <a:latin typeface="Calibri"/>
+              </a:rPr>
+              <a:t>●  1. Fluktuation (Zugang/Abgang) — direkt verfügbar, kein Zusatzaufwand.</a:t>
+            </a:r>
+          </a:p>
+          <a:p>
+            <a:pPr>
+              <a:spcAft>
+                <a:spcPts val="1400"/>
+              </a:spcAft>
+            </a:pPr>
+            <a:r>
+              <a:rPr sz="1800">
+                <a:solidFill>
+                  <a:srgbClr val="374151"/>
+                </a:solidFill>
+                <a:latin typeface="Calibri"/>
+              </a:rPr>
+              <a:t>●  2. Demografie im Zeitverlauf — Alter/Geschlecht als Zeitreihe statt Momentaufnahme.</a:t>
+            </a:r>
+          </a:p>
+          <a:p>
+            <a:pPr>
+              <a:spcAft>
+                <a:spcPts val="1400"/>
+              </a:spcAft>
+            </a:pPr>
+            <a:r>
+              <a:rPr sz="1800">
+                <a:solidFill>
+                  <a:srgbClr val="374151"/>
+                </a:solidFill>
+                <a:latin typeface="Calibri"/>
+              </a:rPr>
+              <a:t>●  3. Erwerbstätigkeit / „Aufstocker“ — erweitert die Trichter-Logik aus Kapitel 3.1.</a:t>
+            </a:r>
+          </a:p>
+          <a:p>
+            <a:pPr>
+              <a:spcAft>
+                <a:spcPts val="1400"/>
+              </a:spcAft>
+            </a:pPr>
+            <a:r>
+              <a:rPr sz="1800">
+                <a:solidFill>
+                  <a:srgbClr val="374151"/>
+                </a:solidFill>
+                <a:latin typeface="Calibri"/>
+              </a:rPr>
+              <a:t>●  4. Finanzen (Zahlungsansprüche) — einzige Quelle für Euro-Beträge.</a:t>
+            </a:r>
+          </a:p>
+          <a:p>
+            <a:pPr>
+              <a:spcAft>
+                <a:spcPts val="1400"/>
+              </a:spcAft>
+            </a:pPr>
+            <a:r>
+              <a:rPr sz="1800">
+                <a:solidFill>
+                  <a:srgbClr val="374151"/>
+                </a:solidFill>
+                <a:latin typeface="Calibri"/>
+              </a:rPr>
+              <a:t>●  5. Förderung (aktive Arbeitsmarktpolitik) — inkl. Aktivierungsquote.</a:t>
+            </a:r>
+          </a:p>
+          <a:p>
+            <a:pPr>
+              <a:spcAft>
+                <a:spcPts val="1400"/>
+              </a:spcAft>
+            </a:pPr>
+            <a:r>
+              <a:rPr sz="1800">
+                <a:solidFill>
+                  <a:srgbClr val="374151"/>
+                </a:solidFill>
+                <a:latin typeface="Calibri"/>
+              </a:rPr>
+              <a:t>●  Nachrangig: Bezugsdauer (Langzeitleistungsbezug, Drehtür-Effekt, Haushaltsgröße).</a:t>
+            </a:r>
+          </a:p>
+          <a:p>
+            <a:pPr>
+              <a:spcAft>
+                <a:spcPts val="1400"/>
+              </a:spcAft>
+            </a:pPr>
+            <a:r>
+              <a:rPr sz="1800">
+                <a:solidFill>
+                  <a:srgbClr val="374151"/>
+                </a:solidFill>
+                <a:latin typeface="Calibri"/>
+              </a:rPr>
+              <a:t>●  Methodisch offen: Korrelation, Streudiagramme, Histogramm/Boxplot, Regression.</a:t>
             </a:r>
           </a:p>
         </p:txBody>
@@ -7023,6 +8846,154 @@
 </p:sld>
 </file>
 
+<file path=ppt/slides/slide30.xml><?xml version="1.0" encoding="utf-8"?>
+<p:sld xmlns:a="http://schemas.openxmlformats.org/drawingml/2006/main" xmlns:r="http://schemas.openxmlformats.org/officeDocument/2006/relationships" xmlns:p="http://schemas.openxmlformats.org/presentationml/2006/main">
+  <p:cSld>
+    <p:bg>
+      <p:bgPr>
+        <a:solidFill>
+          <a:srgbClr val="1E3A8A"/>
+        </a:solidFill>
+        <a:effectLst/>
+      </p:bgPr>
+    </p:bg>
+    <p:spTree>
+      <p:nvGrpSpPr>
+        <p:cNvPr id="1" name=""/>
+        <p:cNvGrpSpPr/>
+        <p:nvPr/>
+      </p:nvGrpSpPr>
+      <p:grpSpPr>
+        <a:xfrm>
+          <a:off x="0" y="0"/>
+          <a:ext cx="0" cy="0"/>
+          <a:chOff x="0" y="0"/>
+          <a:chExt cx="0" cy="0"/>
+        </a:xfrm>
+      </p:grpSpPr>
+      <p:sp>
+        <p:nvSpPr>
+          <p:cNvPr id="2" name="Rectangle 1"/>
+          <p:cNvSpPr/>
+          <p:nvPr/>
+        </p:nvSpPr>
+        <p:spPr>
+          <a:xfrm>
+            <a:off x="0" y="3240000"/>
+            <a:ext cx="12193200" cy="54000"/>
+          </a:xfrm>
+          <a:prstGeom prst="rect">
+            <a:avLst/>
+          </a:prstGeom>
+          <a:solidFill>
+            <a:srgbClr val="F59E0B"/>
+          </a:solidFill>
+          <a:ln>
+            <a:noFill/>
+          </a:ln>
+          <a:effectLst/>
+        </p:spPr>
+        <p:style>
+          <a:lnRef idx="1">
+            <a:schemeClr val="accent1"/>
+          </a:lnRef>
+          <a:fillRef idx="3">
+            <a:schemeClr val="accent1"/>
+          </a:fillRef>
+          <a:effectRef idx="2">
+            <a:schemeClr val="accent1"/>
+          </a:effectRef>
+          <a:fontRef idx="minor">
+            <a:schemeClr val="lt1"/>
+          </a:fontRef>
+        </p:style>
+        <p:txBody>
+          <a:bodyPr rtlCol="0" anchor="ctr"/>
+          <a:lstStyle/>
+          <a:p>
+            <a:pPr algn="ctr"/>
+            <a:endParaRPr/>
+          </a:p>
+        </p:txBody>
+      </p:sp>
+      <p:sp>
+        <p:nvSpPr>
+          <p:cNvPr id="3" name="TextBox 2"/>
+          <p:cNvSpPr txBox="1"/>
+          <p:nvPr/>
+        </p:nvSpPr>
+        <p:spPr>
+          <a:xfrm>
+            <a:off x="720000" y="2484000"/>
+            <a:ext cx="10753200" cy="540000"/>
+          </a:xfrm>
+          <a:prstGeom prst="rect">
+            <a:avLst/>
+          </a:prstGeom>
+          <a:noFill/>
+        </p:spPr>
+        <p:txBody>
+          <a:bodyPr wrap="square" anchor="t">
+            <a:spAutoFit/>
+          </a:bodyPr>
+          <a:lstStyle/>
+          <a:p>
+            <a:pPr algn="ctr"/>
+            <a:r>
+              <a:rPr sz="3600" b="1" i="0">
+                <a:solidFill>
+                  <a:srgbClr val="FFFFFF"/>
+                </a:solidFill>
+                <a:latin typeface="Calibri"/>
+              </a:rPr>
+              <a:t>Vielen Dank für die Aufmerksamkeit</a:t>
+            </a:r>
+          </a:p>
+        </p:txBody>
+      </p:sp>
+      <p:sp>
+        <p:nvSpPr>
+          <p:cNvPr id="4" name="TextBox 3"/>
+          <p:cNvSpPr txBox="1"/>
+          <p:nvPr/>
+        </p:nvSpPr>
+        <p:spPr>
+          <a:xfrm>
+            <a:off x="720000" y="3456000"/>
+            <a:ext cx="10753200" cy="360000"/>
+          </a:xfrm>
+          <a:prstGeom prst="rect">
+            <a:avLst/>
+          </a:prstGeom>
+          <a:noFill/>
+        </p:spPr>
+        <p:txBody>
+          <a:bodyPr wrap="square" anchor="t">
+            <a:spAutoFit/>
+          </a:bodyPr>
+          <a:lstStyle/>
+          <a:p>
+            <a:pPr algn="ctr"/>
+            <a:r>
+              <a:rPr sz="1600" b="0" i="0">
+                <a:solidFill>
+                  <a:srgbClr val="BFDBFE"/>
+                </a:solidFill>
+                <a:latin typeface="Calibri"/>
+              </a:rPr>
+              <a:t>Live-Dashboard: daelwve9mj8pxz32vshq7u.streamlit.app</a:t>
+            </a:r>
+          </a:p>
+        </p:txBody>
+      </p:sp>
+    </p:spTree>
+  </p:cSld>
+  <p:clrMapOvr>
+    <a:masterClrMapping/>
+  </p:clrMapOvr>
+</p:sld>
+</file>
+
 <file path=ppt/slides/slide4.xml><?xml version="1.0" encoding="utf-8"?>
 <p:sld xmlns:a="http://schemas.openxmlformats.org/drawingml/2006/main" xmlns:r="http://schemas.openxmlformats.org/officeDocument/2006/relationships" xmlns:p="http://schemas.openxmlformats.org/presentationml/2006/main">
   <p:cSld>
@@ -7213,7 +9184,7 @@
                 </a:solidFill>
                 <a:latin typeface="Calibri"/>
               </a:rPr>
-              <a:t>●  Ziel: eine strukturierte, reproduzierbare Zeitreihe aus 15 Monatsberichten aufbauen und die Entwicklung der Arbeitslosigkeit im Rechtskreis SGB II auswerten und visualisieren.</a:t>
+              <a:t>●  Ziel: eine strukturierte, reproduzierbare Zeitreihe aus 18 Monatsberichten aufbauen und die Entwicklung der Arbeitslosigkeit im Rechtskreis SGB II auswerten und visualisieren.</a:t>
             </a:r>
           </a:p>
           <a:p>
@@ -7502,7 +9473,7 @@
                 </a:solidFill>
                 <a:latin typeface="Calibri"/>
               </a:rPr>
-              <a:t>15</a:t>
+              <a:t>18</a:t>
             </a:r>
             <a:endParaRPr sz="3000" b="1" i="0">
               <a:solidFill>
@@ -7848,7 +9819,7 @@
                 </a:solidFill>
                 <a:latin typeface="Calibri"/>
               </a:rPr>
-              <a:t>Apr 25 – Jun 26</a:t>
+              <a:t>Jan 25 – Jun 26</a:t>
             </a:r>
           </a:p>
         </p:txBody>
@@ -8736,7 +10707,7 @@
                 </a:solidFill>
                 <a:latin typeface="Calibri"/>
               </a:rPr>
-              <a:t>●  Bereinigung: 0 Duplikate, 90 von 465 fehlenden Werten identifiziert und erklärt.</a:t>
+              <a:t>●  Bereinigung: 0 Duplikate, 108 von 558 fehlenden Werten identifiziert und erklärt.</a:t>
             </a:r>
           </a:p>
           <a:p>
@@ -9041,7 +11012,7 @@
                 </a:solidFill>
                 <a:latin typeface="Calibri"/>
               </a:rPr>
-              <a:t>465 </a:t>
+              <a:t>558 </a:t>
             </a:r>
             <a:r>
               <a:rPr sz="3000" b="1" i="0">
@@ -9421,7 +11392,7 @@
                 </a:solidFill>
                 <a:latin typeface="Calibri"/>
               </a:rPr>
-              <a:t>90 / 465</a:t>
+              <a:t>108 / 558</a:t>
             </a:r>
             <a:endParaRPr sz="3000" b="1" i="0">
               <a:solidFill>

</xml_diff>